<commit_message>
removing slide w/ testing partitions
</commit_message>
<xml_diff>
--- a/scheduling_jobs/scheduling_jobs.pptx
+++ b/scheduling_jobs/scheduling_jobs.pptx
@@ -5,7 +5,7 @@
     <p:sldMasterId id="2147483660" r:id="rId1"/>
   </p:sldMasterIdLst>
   <p:notesMasterIdLst>
-    <p:notesMasterId r:id="rId29"/>
+    <p:notesMasterId r:id="rId28"/>
   </p:notesMasterIdLst>
   <p:sldIdLst>
     <p:sldId id="256" r:id="rId2"/>
@@ -20,42 +20,41 @@
     <p:sldId id="400" r:id="rId11"/>
     <p:sldId id="357" r:id="rId12"/>
     <p:sldId id="394" r:id="rId13"/>
-    <p:sldId id="395" r:id="rId14"/>
-    <p:sldId id="396" r:id="rId15"/>
-    <p:sldId id="354" r:id="rId16"/>
-    <p:sldId id="355" r:id="rId17"/>
-    <p:sldId id="358" r:id="rId18"/>
-    <p:sldId id="397" r:id="rId19"/>
-    <p:sldId id="359" r:id="rId20"/>
-    <p:sldId id="360" r:id="rId21"/>
-    <p:sldId id="361" r:id="rId22"/>
-    <p:sldId id="363" r:id="rId23"/>
-    <p:sldId id="364" r:id="rId24"/>
-    <p:sldId id="398" r:id="rId25"/>
-    <p:sldId id="399" r:id="rId26"/>
-    <p:sldId id="373" r:id="rId27"/>
-    <p:sldId id="392" r:id="rId28"/>
+    <p:sldId id="396" r:id="rId14"/>
+    <p:sldId id="354" r:id="rId15"/>
+    <p:sldId id="355" r:id="rId16"/>
+    <p:sldId id="358" r:id="rId17"/>
+    <p:sldId id="397" r:id="rId18"/>
+    <p:sldId id="359" r:id="rId19"/>
+    <p:sldId id="360" r:id="rId20"/>
+    <p:sldId id="361" r:id="rId21"/>
+    <p:sldId id="363" r:id="rId22"/>
+    <p:sldId id="364" r:id="rId23"/>
+    <p:sldId id="398" r:id="rId24"/>
+    <p:sldId id="399" r:id="rId25"/>
+    <p:sldId id="373" r:id="rId26"/>
+    <p:sldId id="392" r:id="rId27"/>
   </p:sldIdLst>
   <p:sldSz cx="12192000" cy="6858000"/>
   <p:notesSz cx="6858000" cy="9144000"/>
   <p:embeddedFontLst>
     <p:embeddedFont>
       <p:font typeface="Arial Black" panose="020B0604020202020204" pitchFamily="34" charset="0"/>
-      <p:bold r:id="rId30"/>
+      <p:bold r:id="rId29"/>
     </p:embeddedFont>
     <p:embeddedFont>
       <p:font typeface="Century Gothic" panose="020B0502020202020204" pitchFamily="34" charset="0"/>
-      <p:regular r:id="rId31"/>
-      <p:bold r:id="rId32"/>
-      <p:italic r:id="rId33"/>
-      <p:boldItalic r:id="rId34"/>
+      <p:regular r:id="rId30"/>
+      <p:bold r:id="rId31"/>
+      <p:italic r:id="rId32"/>
+      <p:boldItalic r:id="rId33"/>
     </p:embeddedFont>
     <p:embeddedFont>
       <p:font typeface="Consolas" panose="020B0609020204030204" pitchFamily="49" charset="0"/>
-      <p:regular r:id="rId35"/>
-      <p:bold r:id="rId36"/>
-      <p:italic r:id="rId37"/>
-      <p:boldItalic r:id="rId38"/>
+      <p:regular r:id="rId34"/>
+      <p:bold r:id="rId35"/>
+      <p:italic r:id="rId36"/>
+      <p:boldItalic r:id="rId37"/>
     </p:embeddedFont>
   </p:embeddedFontLst>
   <p:defaultTextStyle>
@@ -1977,7 +1976,7 @@
     </p:spTree>
     <p:extLst>
       <p:ext uri="{BB962C8B-B14F-4D97-AF65-F5344CB8AC3E}">
-        <p14:creationId xmlns:p14="http://schemas.microsoft.com/office/powerpoint/2010/main" val="2400582392"/>
+        <p14:creationId xmlns:p14="http://schemas.microsoft.com/office/powerpoint/2010/main" val="2378600619"/>
       </p:ext>
     </p:extLst>
   </p:cSld>
@@ -2094,7 +2093,7 @@
     </p:spTree>
     <p:extLst>
       <p:ext uri="{BB962C8B-B14F-4D97-AF65-F5344CB8AC3E}">
-        <p14:creationId xmlns:p14="http://schemas.microsoft.com/office/powerpoint/2010/main" val="2378600619"/>
+        <p14:creationId xmlns:p14="http://schemas.microsoft.com/office/powerpoint/2010/main" val="2799839072"/>
       </p:ext>
     </p:extLst>
   </p:cSld>
@@ -2194,7 +2193,7 @@
                 <a:cs typeface="Calibri"/>
                 <a:sym typeface="Calibri"/>
               </a:rPr>
-              <a:t>18</a:t>
+              <a:t>17</a:t>
             </a:fld>
             <a:endParaRPr lang="en-US" sz="1200" b="0" i="0" u="none" strike="noStrike" cap="none">
               <a:solidFill>
@@ -20078,2236 +20077,6 @@
 </file>
 
 <file path=ppt/slides/slide13.xml><?xml version="1.0" encoding="utf-8"?>
-<p:sld xmlns:a="http://schemas.openxmlformats.org/drawingml/2006/main" xmlns:r="http://schemas.openxmlformats.org/officeDocument/2006/relationships" xmlns:p="http://schemas.openxmlformats.org/presentationml/2006/main" show="0">
-  <p:cSld>
-    <p:spTree>
-      <p:nvGrpSpPr>
-        <p:cNvPr id="1" name="">
-          <a:extLst>
-            <a:ext uri="{FF2B5EF4-FFF2-40B4-BE49-F238E27FC236}">
-              <a16:creationId xmlns:a16="http://schemas.microsoft.com/office/drawing/2014/main" id="{9CDF72F4-AC02-54B3-90D1-BED586865FEA}"/>
-            </a:ext>
-          </a:extLst>
-        </p:cNvPr>
-        <p:cNvGrpSpPr/>
-        <p:nvPr/>
-      </p:nvGrpSpPr>
-      <p:grpSpPr>
-        <a:xfrm>
-          <a:off x="0" y="0"/>
-          <a:ext cx="0" cy="0"/>
-          <a:chOff x="0" y="0"/>
-          <a:chExt cx="0" cy="0"/>
-        </a:xfrm>
-      </p:grpSpPr>
-      <p:sp>
-        <p:nvSpPr>
-          <p:cNvPr id="2" name="Title 1">
-            <a:extLst>
-              <a:ext uri="{FF2B5EF4-FFF2-40B4-BE49-F238E27FC236}">
-                <a16:creationId xmlns:a16="http://schemas.microsoft.com/office/drawing/2014/main" id="{7F4A3909-28CE-59E4-61B3-932570CC80C5}"/>
-              </a:ext>
-            </a:extLst>
-          </p:cNvPr>
-          <p:cNvSpPr>
-            <a:spLocks noGrp="1"/>
-          </p:cNvSpPr>
-          <p:nvPr>
-            <p:ph type="title"/>
-          </p:nvPr>
-        </p:nvSpPr>
-        <p:spPr>
-          <a:xfrm>
-            <a:off x="838200" y="136525"/>
-            <a:ext cx="10515600" cy="1325563"/>
-          </a:xfrm>
-        </p:spPr>
-        <p:txBody>
-          <a:bodyPr/>
-          <a:lstStyle/>
-          <a:p>
-            <a:r>
-              <a:rPr lang="en-US" b="1" dirty="0">
-                <a:latin typeface="Century Gothic" panose="020B0502020202020204" pitchFamily="34" charset="0"/>
-                <a:cs typeface="Helvetica Neue Light"/>
-                <a:sym typeface="Helvetica Neue Light"/>
-              </a:rPr>
-              <a:t>Alpine Testing Partitions</a:t>
-            </a:r>
-            <a:endParaRPr lang="en-US" b="1" dirty="0">
-              <a:latin typeface="Century Gothic" panose="020B0502020202020204" pitchFamily="34" charset="0"/>
-            </a:endParaRPr>
-          </a:p>
-        </p:txBody>
-      </p:sp>
-      <p:sp>
-        <p:nvSpPr>
-          <p:cNvPr id="3" name="Content Placeholder 2">
-            <a:extLst>
-              <a:ext uri="{FF2B5EF4-FFF2-40B4-BE49-F238E27FC236}">
-                <a16:creationId xmlns:a16="http://schemas.microsoft.com/office/drawing/2014/main" id="{21B9EBED-13AB-034F-CFD7-00FB1DAC0B86}"/>
-              </a:ext>
-            </a:extLst>
-          </p:cNvPr>
-          <p:cNvSpPr>
-            <a:spLocks noGrp="1"/>
-          </p:cNvSpPr>
-          <p:nvPr>
-            <p:ph idx="1"/>
-          </p:nvPr>
-        </p:nvSpPr>
-        <p:spPr>
-          <a:xfrm>
-            <a:off x="838200" y="1378805"/>
-            <a:ext cx="10515600" cy="1549034"/>
-          </a:xfrm>
-        </p:spPr>
-        <p:txBody>
-          <a:bodyPr>
-            <a:normAutofit fontScale="92500" lnSpcReduction="20000"/>
-          </a:bodyPr>
-          <a:lstStyle/>
-          <a:p>
-            <a:r>
-              <a:rPr lang="en-US" dirty="0"/>
-              <a:t>For many of the partitions we have testing partitions that provide quicker access to resources. </a:t>
-            </a:r>
-          </a:p>
-          <a:p>
-            <a:pPr marL="0" indent="0">
-              <a:buNone/>
-            </a:pPr>
-            <a:r>
-              <a:rPr lang="en-US" b="1" u="sng" dirty="0"/>
-              <a:t>Note: </a:t>
-            </a:r>
-            <a:r>
-              <a:rPr lang="en-US" dirty="0"/>
-              <a:t>there are restrictions on the amount of resources you can request. These restrictions can be found in our documentation.  </a:t>
-            </a:r>
-          </a:p>
-        </p:txBody>
-      </p:sp>
-      <p:sp>
-        <p:nvSpPr>
-          <p:cNvPr id="4" name="Date Placeholder 3">
-            <a:extLst>
-              <a:ext uri="{FF2B5EF4-FFF2-40B4-BE49-F238E27FC236}">
-                <a16:creationId xmlns:a16="http://schemas.microsoft.com/office/drawing/2014/main" id="{CE63D458-0B66-49A0-502A-DCE4C7E0AF0A}"/>
-              </a:ext>
-            </a:extLst>
-          </p:cNvPr>
-          <p:cNvSpPr>
-            <a:spLocks noGrp="1"/>
-          </p:cNvSpPr>
-          <p:nvPr>
-            <p:ph type="dt" sz="half" idx="10"/>
-          </p:nvPr>
-        </p:nvSpPr>
-        <p:spPr/>
-        <p:txBody>
-          <a:bodyPr/>
-          <a:lstStyle/>
-          <a:p>
-            <a:pPr algn="ctr"/>
-            <a:r>
-              <a:rPr lang="en-US"/>
-              <a:t>8/12/26</a:t>
-            </a:r>
-          </a:p>
-        </p:txBody>
-      </p:sp>
-      <p:graphicFrame>
-        <p:nvGraphicFramePr>
-          <p:cNvPr id="6" name="Google Shape;833;p68">
-            <a:extLst>
-              <a:ext uri="{FF2B5EF4-FFF2-40B4-BE49-F238E27FC236}">
-                <a16:creationId xmlns:a16="http://schemas.microsoft.com/office/drawing/2014/main" id="{EC46FB0D-D7D1-CB1A-6CBD-5805716EE2C3}"/>
-              </a:ext>
-            </a:extLst>
-          </p:cNvPr>
-          <p:cNvGraphicFramePr/>
-          <p:nvPr/>
-        </p:nvGraphicFramePr>
-        <p:xfrm>
-          <a:off x="838200" y="3107748"/>
-          <a:ext cx="10218825" cy="3174200"/>
-        </p:xfrm>
-        <a:graphic>
-          <a:graphicData uri="http://schemas.openxmlformats.org/drawingml/2006/table">
-            <a:tbl>
-              <a:tblPr>
-                <a:noFill/>
-              </a:tblPr>
-              <a:tblGrid>
-                <a:gridCol w="2165750">
-                  <a:extLst>
-                    <a:ext uri="{9D8B030D-6E8A-4147-A177-3AD203B41FA5}">
-                      <a16:colId xmlns:a16="http://schemas.microsoft.com/office/drawing/2014/main" val="20000"/>
-                    </a:ext>
-                  </a:extLst>
-                </a:gridCol>
-                <a:gridCol w="2173000">
-                  <a:extLst>
-                    <a:ext uri="{9D8B030D-6E8A-4147-A177-3AD203B41FA5}">
-                      <a16:colId xmlns:a16="http://schemas.microsoft.com/office/drawing/2014/main" val="20001"/>
-                    </a:ext>
-                  </a:extLst>
-                </a:gridCol>
-                <a:gridCol w="1190700">
-                  <a:extLst>
-                    <a:ext uri="{9D8B030D-6E8A-4147-A177-3AD203B41FA5}">
-                      <a16:colId xmlns:a16="http://schemas.microsoft.com/office/drawing/2014/main" val="20002"/>
-                    </a:ext>
-                  </a:extLst>
-                </a:gridCol>
-                <a:gridCol w="1326775">
-                  <a:extLst>
-                    <a:ext uri="{9D8B030D-6E8A-4147-A177-3AD203B41FA5}">
-                      <a16:colId xmlns:a16="http://schemas.microsoft.com/office/drawing/2014/main" val="20003"/>
-                    </a:ext>
-                  </a:extLst>
-                </a:gridCol>
-                <a:gridCol w="1326775">
-                  <a:extLst>
-                    <a:ext uri="{9D8B030D-6E8A-4147-A177-3AD203B41FA5}">
-                      <a16:colId xmlns:a16="http://schemas.microsoft.com/office/drawing/2014/main" val="20004"/>
-                    </a:ext>
-                  </a:extLst>
-                </a:gridCol>
-                <a:gridCol w="2035825">
-                  <a:extLst>
-                    <a:ext uri="{9D8B030D-6E8A-4147-A177-3AD203B41FA5}">
-                      <a16:colId xmlns:a16="http://schemas.microsoft.com/office/drawing/2014/main" val="20005"/>
-                    </a:ext>
-                  </a:extLst>
-                </a:gridCol>
-              </a:tblGrid>
-              <a:tr h="300800">
-                <a:tc>
-                  <a:txBody>
-                    <a:bodyPr/>
-                    <a:lstStyle/>
-                    <a:p>
-                      <a:pPr marL="0" marR="0" lvl="0" indent="0" algn="l" rtl="0">
-                        <a:spcBef>
-                          <a:spcPts val="0"/>
-                        </a:spcBef>
-                        <a:spcAft>
-                          <a:spcPts val="0"/>
-                        </a:spcAft>
-                        <a:buNone/>
-                      </a:pPr>
-                      <a:r>
-                        <a:rPr lang="en-US" sz="1800" b="1" i="0" u="none" strike="noStrike" cap="none" dirty="0">
-                          <a:solidFill>
-                            <a:srgbClr val="000000"/>
-                          </a:solidFill>
-                          <a:latin typeface="Arial"/>
-                          <a:ea typeface="Arial"/>
-                          <a:cs typeface="Arial"/>
-                          <a:sym typeface="Arial"/>
-                        </a:rPr>
-                        <a:t>Partition</a:t>
-                      </a:r>
-                      <a:endParaRPr dirty="0"/>
-                    </a:p>
-                  </a:txBody>
-                  <a:tcPr marL="43100" marR="43100" marT="43100" marB="43100">
-                    <a:lnL w="9525" cap="flat" cmpd="sng">
-                      <a:solidFill>
-                        <a:srgbClr val="000000"/>
-                      </a:solidFill>
-                      <a:prstDash val="solid"/>
-                      <a:round/>
-                      <a:headEnd type="none" w="sm" len="sm"/>
-                      <a:tailEnd type="none" w="sm" len="sm"/>
-                    </a:lnL>
-                    <a:lnR w="9525" cap="flat" cmpd="sng">
-                      <a:solidFill>
-                        <a:srgbClr val="000000"/>
-                      </a:solidFill>
-                      <a:prstDash val="solid"/>
-                      <a:round/>
-                      <a:headEnd type="none" w="sm" len="sm"/>
-                      <a:tailEnd type="none" w="sm" len="sm"/>
-                    </a:lnR>
-                    <a:lnT w="9525" cap="flat" cmpd="sng">
-                      <a:solidFill>
-                        <a:srgbClr val="000000"/>
-                      </a:solidFill>
-                      <a:prstDash val="solid"/>
-                      <a:round/>
-                      <a:headEnd type="none" w="sm" len="sm"/>
-                      <a:tailEnd type="none" w="sm" len="sm"/>
-                    </a:lnT>
-                    <a:lnB w="9525" cap="flat" cmpd="sng">
-                      <a:solidFill>
-                        <a:srgbClr val="000000"/>
-                      </a:solidFill>
-                      <a:prstDash val="solid"/>
-                      <a:round/>
-                      <a:headEnd type="none" w="sm" len="sm"/>
-                      <a:tailEnd type="none" w="sm" len="sm"/>
-                    </a:lnB>
-                  </a:tcPr>
-                </a:tc>
-                <a:tc>
-                  <a:txBody>
-                    <a:bodyPr/>
-                    <a:lstStyle/>
-                    <a:p>
-                      <a:pPr marL="0" marR="0" lvl="0" indent="0" algn="l" rtl="0">
-                        <a:spcBef>
-                          <a:spcPts val="0"/>
-                        </a:spcBef>
-                        <a:spcAft>
-                          <a:spcPts val="0"/>
-                        </a:spcAft>
-                        <a:buNone/>
-                      </a:pPr>
-                      <a:r>
-                        <a:rPr lang="en-US" sz="1800" b="1" i="0" u="none" strike="noStrike" cap="none">
-                          <a:solidFill>
-                            <a:srgbClr val="000000"/>
-                          </a:solidFill>
-                          <a:latin typeface="Arial"/>
-                          <a:ea typeface="Arial"/>
-                          <a:cs typeface="Arial"/>
-                          <a:sym typeface="Arial"/>
-                        </a:rPr>
-                        <a:t>Description</a:t>
-                      </a:r>
-                      <a:endParaRPr sz="1800" b="1" u="none" strike="noStrike" cap="none"/>
-                    </a:p>
-                  </a:txBody>
-                  <a:tcPr marL="43100" marR="43100" marT="43100" marB="43100">
-                    <a:lnL w="9525" cap="flat" cmpd="sng">
-                      <a:solidFill>
-                        <a:srgbClr val="000000"/>
-                      </a:solidFill>
-                      <a:prstDash val="solid"/>
-                      <a:round/>
-                      <a:headEnd type="none" w="sm" len="sm"/>
-                      <a:tailEnd type="none" w="sm" len="sm"/>
-                    </a:lnL>
-                    <a:lnR w="9525" cap="flat" cmpd="sng">
-                      <a:solidFill>
-                        <a:srgbClr val="000000"/>
-                      </a:solidFill>
-                      <a:prstDash val="solid"/>
-                      <a:round/>
-                      <a:headEnd type="none" w="sm" len="sm"/>
-                      <a:tailEnd type="none" w="sm" len="sm"/>
-                    </a:lnR>
-                    <a:lnT w="9525" cap="flat" cmpd="sng">
-                      <a:solidFill>
-                        <a:srgbClr val="000000"/>
-                      </a:solidFill>
-                      <a:prstDash val="solid"/>
-                      <a:round/>
-                      <a:headEnd type="none" w="sm" len="sm"/>
-                      <a:tailEnd type="none" w="sm" len="sm"/>
-                    </a:lnT>
-                    <a:lnB w="9525" cap="flat" cmpd="sng">
-                      <a:solidFill>
-                        <a:srgbClr val="000000"/>
-                      </a:solidFill>
-                      <a:prstDash val="solid"/>
-                      <a:round/>
-                      <a:headEnd type="none" w="sm" len="sm"/>
-                      <a:tailEnd type="none" w="sm" len="sm"/>
-                    </a:lnB>
-                  </a:tcPr>
-                </a:tc>
-                <a:tc>
-                  <a:txBody>
-                    <a:bodyPr/>
-                    <a:lstStyle/>
-                    <a:p>
-                      <a:pPr marL="0" marR="0" lvl="0" indent="0" algn="l" rtl="0">
-                        <a:spcBef>
-                          <a:spcPts val="0"/>
-                        </a:spcBef>
-                        <a:spcAft>
-                          <a:spcPts val="0"/>
-                        </a:spcAft>
-                        <a:buNone/>
-                      </a:pPr>
-                      <a:r>
-                        <a:rPr lang="en-US" sz="1800" b="1" i="0" u="none" strike="noStrike" cap="none">
-                          <a:solidFill>
-                            <a:srgbClr val="000000"/>
-                          </a:solidFill>
-                          <a:latin typeface="Arial"/>
-                          <a:ea typeface="Arial"/>
-                          <a:cs typeface="Arial"/>
-                          <a:sym typeface="Arial"/>
-                        </a:rPr>
-                        <a:t># of nodes</a:t>
-                      </a:r>
-                      <a:endParaRPr sz="1800" b="1" u="none" strike="noStrike" cap="none"/>
-                    </a:p>
-                  </a:txBody>
-                  <a:tcPr marL="43100" marR="43100" marT="43100" marB="43100">
-                    <a:lnL w="9525" cap="flat" cmpd="sng">
-                      <a:solidFill>
-                        <a:srgbClr val="000000"/>
-                      </a:solidFill>
-                      <a:prstDash val="solid"/>
-                      <a:round/>
-                      <a:headEnd type="none" w="sm" len="sm"/>
-                      <a:tailEnd type="none" w="sm" len="sm"/>
-                    </a:lnL>
-                    <a:lnR w="9525" cap="flat" cmpd="sng">
-                      <a:solidFill>
-                        <a:srgbClr val="000000"/>
-                      </a:solidFill>
-                      <a:prstDash val="solid"/>
-                      <a:round/>
-                      <a:headEnd type="none" w="sm" len="sm"/>
-                      <a:tailEnd type="none" w="sm" len="sm"/>
-                    </a:lnR>
-                    <a:lnT w="9525" cap="flat" cmpd="sng">
-                      <a:solidFill>
-                        <a:srgbClr val="000000"/>
-                      </a:solidFill>
-                      <a:prstDash val="solid"/>
-                      <a:round/>
-                      <a:headEnd type="none" w="sm" len="sm"/>
-                      <a:tailEnd type="none" w="sm" len="sm"/>
-                    </a:lnT>
-                    <a:lnB w="9525" cap="flat" cmpd="sng">
-                      <a:solidFill>
-                        <a:srgbClr val="000000"/>
-                      </a:solidFill>
-                      <a:prstDash val="solid"/>
-                      <a:round/>
-                      <a:headEnd type="none" w="sm" len="sm"/>
-                      <a:tailEnd type="none" w="sm" len="sm"/>
-                    </a:lnB>
-                  </a:tcPr>
-                </a:tc>
-                <a:tc>
-                  <a:txBody>
-                    <a:bodyPr/>
-                    <a:lstStyle/>
-                    <a:p>
-                      <a:pPr marL="0" marR="0" lvl="0" indent="0" algn="l" rtl="0">
-                        <a:spcBef>
-                          <a:spcPts val="0"/>
-                        </a:spcBef>
-                        <a:spcAft>
-                          <a:spcPts val="0"/>
-                        </a:spcAft>
-                        <a:buNone/>
-                      </a:pPr>
-                      <a:r>
-                        <a:rPr lang="en-US" sz="1800" b="1"/>
-                        <a:t>RAM/core (GB)</a:t>
-                      </a:r>
-                      <a:endParaRPr sz="1800" b="1" i="0" u="none" strike="noStrike" cap="none">
-                        <a:solidFill>
-                          <a:srgbClr val="000000"/>
-                        </a:solidFill>
-                        <a:latin typeface="Arial"/>
-                        <a:ea typeface="Arial"/>
-                        <a:cs typeface="Arial"/>
-                        <a:sym typeface="Arial"/>
-                      </a:endParaRPr>
-                    </a:p>
-                  </a:txBody>
-                  <a:tcPr marL="43100" marR="43100" marT="43100" marB="43100">
-                    <a:lnL w="9525" cap="flat" cmpd="sng">
-                      <a:solidFill>
-                        <a:srgbClr val="000000"/>
-                      </a:solidFill>
-                      <a:prstDash val="solid"/>
-                      <a:round/>
-                      <a:headEnd type="none" w="sm" len="sm"/>
-                      <a:tailEnd type="none" w="sm" len="sm"/>
-                    </a:lnL>
-                    <a:lnR w="9525" cap="flat" cmpd="sng">
-                      <a:solidFill>
-                        <a:srgbClr val="000000"/>
-                      </a:solidFill>
-                      <a:prstDash val="solid"/>
-                      <a:round/>
-                      <a:headEnd type="none" w="sm" len="sm"/>
-                      <a:tailEnd type="none" w="sm" len="sm"/>
-                    </a:lnR>
-                    <a:lnT w="9525" cap="flat" cmpd="sng">
-                      <a:solidFill>
-                        <a:srgbClr val="000000"/>
-                      </a:solidFill>
-                      <a:prstDash val="solid"/>
-                      <a:round/>
-                      <a:headEnd type="none" w="sm" len="sm"/>
-                      <a:tailEnd type="none" w="sm" len="sm"/>
-                    </a:lnT>
-                    <a:lnB w="9525" cap="flat" cmpd="sng">
-                      <a:solidFill>
-                        <a:srgbClr val="000000"/>
-                      </a:solidFill>
-                      <a:prstDash val="solid"/>
-                      <a:round/>
-                      <a:headEnd type="none" w="sm" len="sm"/>
-                      <a:tailEnd type="none" w="sm" len="sm"/>
-                    </a:lnB>
-                  </a:tcPr>
-                </a:tc>
-                <a:tc>
-                  <a:txBody>
-                    <a:bodyPr/>
-                    <a:lstStyle/>
-                    <a:p>
-                      <a:pPr marL="0" marR="0" lvl="0" indent="0" algn="l" rtl="0">
-                        <a:spcBef>
-                          <a:spcPts val="0"/>
-                        </a:spcBef>
-                        <a:spcAft>
-                          <a:spcPts val="0"/>
-                        </a:spcAft>
-                        <a:buNone/>
-                      </a:pPr>
-                      <a:r>
-                        <a:rPr lang="en-US" sz="1800" b="1" i="0" u="none" strike="noStrike" cap="none">
-                          <a:solidFill>
-                            <a:srgbClr val="000000"/>
-                          </a:solidFill>
-                          <a:latin typeface="Arial"/>
-                          <a:ea typeface="Arial"/>
-                          <a:cs typeface="Arial"/>
-                          <a:sym typeface="Arial"/>
-                        </a:rPr>
-                        <a:t>cores/node</a:t>
-                      </a:r>
-                      <a:endParaRPr sz="1800" b="1" u="none" strike="noStrike" cap="none"/>
-                    </a:p>
-                  </a:txBody>
-                  <a:tcPr marL="43100" marR="43100" marT="43100" marB="43100">
-                    <a:lnL w="9525" cap="flat" cmpd="sng">
-                      <a:solidFill>
-                        <a:srgbClr val="000000"/>
-                      </a:solidFill>
-                      <a:prstDash val="solid"/>
-                      <a:round/>
-                      <a:headEnd type="none" w="sm" len="sm"/>
-                      <a:tailEnd type="none" w="sm" len="sm"/>
-                    </a:lnL>
-                    <a:lnR w="9525" cap="flat" cmpd="sng">
-                      <a:solidFill>
-                        <a:srgbClr val="000000"/>
-                      </a:solidFill>
-                      <a:prstDash val="solid"/>
-                      <a:round/>
-                      <a:headEnd type="none" w="sm" len="sm"/>
-                      <a:tailEnd type="none" w="sm" len="sm"/>
-                    </a:lnR>
-                    <a:lnT w="9525" cap="flat" cmpd="sng">
-                      <a:solidFill>
-                        <a:srgbClr val="000000"/>
-                      </a:solidFill>
-                      <a:prstDash val="solid"/>
-                      <a:round/>
-                      <a:headEnd type="none" w="sm" len="sm"/>
-                      <a:tailEnd type="none" w="sm" len="sm"/>
-                    </a:lnT>
-                    <a:lnB w="9525" cap="flat" cmpd="sng">
-                      <a:solidFill>
-                        <a:srgbClr val="000000"/>
-                      </a:solidFill>
-                      <a:prstDash val="solid"/>
-                      <a:round/>
-                      <a:headEnd type="none" w="sm" len="sm"/>
-                      <a:tailEnd type="none" w="sm" len="sm"/>
-                    </a:lnB>
-                  </a:tcPr>
-                </a:tc>
-                <a:tc>
-                  <a:txBody>
-                    <a:bodyPr/>
-                    <a:lstStyle/>
-                    <a:p>
-                      <a:pPr marL="0" marR="0" lvl="0" indent="0" algn="l" rtl="0">
-                        <a:spcBef>
-                          <a:spcPts val="0"/>
-                        </a:spcBef>
-                        <a:spcAft>
-                          <a:spcPts val="0"/>
-                        </a:spcAft>
-                        <a:buNone/>
-                      </a:pPr>
-                      <a:r>
-                        <a:rPr lang="en-US" sz="1800" b="1" i="0" u="none" strike="noStrike" cap="none" dirty="0">
-                          <a:solidFill>
-                            <a:srgbClr val="000000"/>
-                          </a:solidFill>
-                          <a:latin typeface="Arial"/>
-                          <a:ea typeface="Arial"/>
-                          <a:cs typeface="Arial"/>
-                          <a:sym typeface="Arial"/>
-                        </a:rPr>
-                        <a:t>GPUs/node</a:t>
-                      </a:r>
-                      <a:endParaRPr sz="1800" b="1" u="none" strike="noStrike" cap="none" dirty="0"/>
-                    </a:p>
-                  </a:txBody>
-                  <a:tcPr marL="43100" marR="43100" marT="43100" marB="43100">
-                    <a:lnL w="9525" cap="flat" cmpd="sng">
-                      <a:solidFill>
-                        <a:srgbClr val="000000"/>
-                      </a:solidFill>
-                      <a:prstDash val="solid"/>
-                      <a:round/>
-                      <a:headEnd type="none" w="sm" len="sm"/>
-                      <a:tailEnd type="none" w="sm" len="sm"/>
-                    </a:lnL>
-                    <a:lnR w="9525" cap="flat" cmpd="sng">
-                      <a:solidFill>
-                        <a:srgbClr val="000000"/>
-                      </a:solidFill>
-                      <a:prstDash val="solid"/>
-                      <a:round/>
-                      <a:headEnd type="none" w="sm" len="sm"/>
-                      <a:tailEnd type="none" w="sm" len="sm"/>
-                    </a:lnR>
-                    <a:lnT w="9525" cap="flat" cmpd="sng">
-                      <a:solidFill>
-                        <a:srgbClr val="000000"/>
-                      </a:solidFill>
-                      <a:prstDash val="solid"/>
-                      <a:round/>
-                      <a:headEnd type="none" w="sm" len="sm"/>
-                      <a:tailEnd type="none" w="sm" len="sm"/>
-                    </a:lnT>
-                    <a:lnB w="9525" cap="flat" cmpd="sng">
-                      <a:solidFill>
-                        <a:srgbClr val="000000"/>
-                      </a:solidFill>
-                      <a:prstDash val="solid"/>
-                      <a:round/>
-                      <a:headEnd type="none" w="sm" len="sm"/>
-                      <a:tailEnd type="none" w="sm" len="sm"/>
-                    </a:lnB>
-                  </a:tcPr>
-                </a:tc>
-                <a:extLst>
-                  <a:ext uri="{0D108BD9-81ED-4DB2-BD59-A6C34878D82A}">
-                    <a16:rowId xmlns:a16="http://schemas.microsoft.com/office/drawing/2014/main" val="10000"/>
-                  </a:ext>
-                </a:extLst>
-              </a:tr>
-              <a:tr h="495175">
-                <a:tc>
-                  <a:txBody>
-                    <a:bodyPr/>
-                    <a:lstStyle/>
-                    <a:p>
-                      <a:pPr marL="0" marR="0" lvl="0" indent="0" algn="l" rtl="0">
-                        <a:spcBef>
-                          <a:spcPts val="0"/>
-                        </a:spcBef>
-                        <a:spcAft>
-                          <a:spcPts val="0"/>
-                        </a:spcAft>
-                        <a:buNone/>
-                      </a:pPr>
-                      <a:r>
-                        <a:rPr lang="en-US" sz="1800" dirty="0" err="1"/>
-                        <a:t>atesting</a:t>
-                      </a:r>
-                      <a:endParaRPr dirty="0"/>
-                    </a:p>
-                  </a:txBody>
-                  <a:tcPr marL="43100" marR="43100" marT="43100" marB="43100">
-                    <a:lnL w="9525" cap="flat" cmpd="sng">
-                      <a:solidFill>
-                        <a:srgbClr val="000000"/>
-                      </a:solidFill>
-                      <a:prstDash val="solid"/>
-                      <a:round/>
-                      <a:headEnd type="none" w="sm" len="sm"/>
-                      <a:tailEnd type="none" w="sm" len="sm"/>
-                    </a:lnL>
-                    <a:lnR w="9525" cap="flat" cmpd="sng">
-                      <a:solidFill>
-                        <a:srgbClr val="000000"/>
-                      </a:solidFill>
-                      <a:prstDash val="solid"/>
-                      <a:round/>
-                      <a:headEnd type="none" w="sm" len="sm"/>
-                      <a:tailEnd type="none" w="sm" len="sm"/>
-                    </a:lnR>
-                    <a:lnT w="9525" cap="flat" cmpd="sng">
-                      <a:solidFill>
-                        <a:srgbClr val="000000"/>
-                      </a:solidFill>
-                      <a:prstDash val="solid"/>
-                      <a:round/>
-                      <a:headEnd type="none" w="sm" len="sm"/>
-                      <a:tailEnd type="none" w="sm" len="sm"/>
-                    </a:lnT>
-                    <a:lnB w="9525" cap="flat" cmpd="sng">
-                      <a:solidFill>
-                        <a:srgbClr val="000000"/>
-                      </a:solidFill>
-                      <a:prstDash val="solid"/>
-                      <a:round/>
-                      <a:headEnd type="none" w="sm" len="sm"/>
-                      <a:tailEnd type="none" w="sm" len="sm"/>
-                    </a:lnB>
-                  </a:tcPr>
-                </a:tc>
-                <a:tc>
-                  <a:txBody>
-                    <a:bodyPr/>
-                    <a:lstStyle/>
-                    <a:p>
-                      <a:pPr marL="0" marR="0" lvl="0" indent="0" algn="l" rtl="0">
-                        <a:spcBef>
-                          <a:spcPts val="0"/>
-                        </a:spcBef>
-                        <a:spcAft>
-                          <a:spcPts val="0"/>
-                        </a:spcAft>
-                        <a:buNone/>
-                      </a:pPr>
-                      <a:r>
-                        <a:rPr lang="en-US" sz="1800" b="0" i="0" u="none" strike="noStrike" cap="none">
-                          <a:solidFill>
-                            <a:srgbClr val="000000"/>
-                          </a:solidFill>
-                          <a:latin typeface="Arial"/>
-                          <a:ea typeface="Arial"/>
-                          <a:cs typeface="Arial"/>
-                          <a:sym typeface="Arial"/>
-                        </a:rPr>
-                        <a:t>General Compute Node</a:t>
-                      </a:r>
-                      <a:r>
-                        <a:rPr lang="en-US" sz="1800"/>
-                        <a:t>: AMD Milan</a:t>
-                      </a:r>
-                      <a:r>
-                        <a:rPr lang="en-US" sz="1800" b="0" i="0" u="none" strike="noStrike" cap="none">
-                          <a:solidFill>
-                            <a:srgbClr val="000000"/>
-                          </a:solidFill>
-                          <a:latin typeface="Arial"/>
-                          <a:ea typeface="Arial"/>
-                          <a:cs typeface="Arial"/>
-                          <a:sym typeface="Arial"/>
-                        </a:rPr>
-                        <a:t> </a:t>
-                      </a:r>
-                      <a:endParaRPr sz="1800" u="none" strike="noStrike" cap="none"/>
-                    </a:p>
-                  </a:txBody>
-                  <a:tcPr marL="43100" marR="43100" marT="43100" marB="43100">
-                    <a:lnL w="9525" cap="flat" cmpd="sng">
-                      <a:solidFill>
-                        <a:srgbClr val="000000"/>
-                      </a:solidFill>
-                      <a:prstDash val="solid"/>
-                      <a:round/>
-                      <a:headEnd type="none" w="sm" len="sm"/>
-                      <a:tailEnd type="none" w="sm" len="sm"/>
-                    </a:lnL>
-                    <a:lnR w="9525" cap="flat" cmpd="sng">
-                      <a:solidFill>
-                        <a:srgbClr val="000000"/>
-                      </a:solidFill>
-                      <a:prstDash val="solid"/>
-                      <a:round/>
-                      <a:headEnd type="none" w="sm" len="sm"/>
-                      <a:tailEnd type="none" w="sm" len="sm"/>
-                    </a:lnR>
-                    <a:lnT w="9525" cap="flat" cmpd="sng">
-                      <a:solidFill>
-                        <a:srgbClr val="000000"/>
-                      </a:solidFill>
-                      <a:prstDash val="solid"/>
-                      <a:round/>
-                      <a:headEnd type="none" w="sm" len="sm"/>
-                      <a:tailEnd type="none" w="sm" len="sm"/>
-                    </a:lnT>
-                    <a:lnB w="9525" cap="flat" cmpd="sng">
-                      <a:solidFill>
-                        <a:srgbClr val="000000"/>
-                      </a:solidFill>
-                      <a:prstDash val="solid"/>
-                      <a:round/>
-                      <a:headEnd type="none" w="sm" len="sm"/>
-                      <a:tailEnd type="none" w="sm" len="sm"/>
-                    </a:lnB>
-                  </a:tcPr>
-                </a:tc>
-                <a:tc>
-                  <a:txBody>
-                    <a:bodyPr/>
-                    <a:lstStyle/>
-                    <a:p>
-                      <a:pPr marL="0" marR="0" lvl="0" indent="0" algn="l" rtl="0">
-                        <a:spcBef>
-                          <a:spcPts val="0"/>
-                        </a:spcBef>
-                        <a:spcAft>
-                          <a:spcPts val="0"/>
-                        </a:spcAft>
-                        <a:buNone/>
-                      </a:pPr>
-                      <a:r>
-                        <a:rPr lang="en-US" sz="1800" u="none" strike="noStrike" cap="none" dirty="0"/>
-                        <a:t>2</a:t>
-                      </a:r>
-                      <a:endParaRPr sz="1800" u="none" strike="noStrike" cap="none" dirty="0"/>
-                    </a:p>
-                  </a:txBody>
-                  <a:tcPr marL="43100" marR="43100" marT="43100" marB="43100">
-                    <a:lnL w="9525" cap="flat" cmpd="sng">
-                      <a:solidFill>
-                        <a:srgbClr val="000000"/>
-                      </a:solidFill>
-                      <a:prstDash val="solid"/>
-                      <a:round/>
-                      <a:headEnd type="none" w="sm" len="sm"/>
-                      <a:tailEnd type="none" w="sm" len="sm"/>
-                    </a:lnL>
-                    <a:lnR w="9525" cap="flat" cmpd="sng">
-                      <a:solidFill>
-                        <a:srgbClr val="000000"/>
-                      </a:solidFill>
-                      <a:prstDash val="solid"/>
-                      <a:round/>
-                      <a:headEnd type="none" w="sm" len="sm"/>
-                      <a:tailEnd type="none" w="sm" len="sm"/>
-                    </a:lnR>
-                    <a:lnT w="9525" cap="flat" cmpd="sng">
-                      <a:solidFill>
-                        <a:srgbClr val="000000"/>
-                      </a:solidFill>
-                      <a:prstDash val="solid"/>
-                      <a:round/>
-                      <a:headEnd type="none" w="sm" len="sm"/>
-                      <a:tailEnd type="none" w="sm" len="sm"/>
-                    </a:lnT>
-                    <a:lnB w="9525" cap="flat" cmpd="sng">
-                      <a:solidFill>
-                        <a:srgbClr val="000000"/>
-                      </a:solidFill>
-                      <a:prstDash val="solid"/>
-                      <a:round/>
-                      <a:headEnd type="none" w="sm" len="sm"/>
-                      <a:tailEnd type="none" w="sm" len="sm"/>
-                    </a:lnB>
-                  </a:tcPr>
-                </a:tc>
-                <a:tc>
-                  <a:txBody>
-                    <a:bodyPr/>
-                    <a:lstStyle/>
-                    <a:p>
-                      <a:pPr marL="0" marR="0" lvl="0" indent="0" algn="l" rtl="0">
-                        <a:spcBef>
-                          <a:spcPts val="0"/>
-                        </a:spcBef>
-                        <a:spcAft>
-                          <a:spcPts val="0"/>
-                        </a:spcAft>
-                        <a:buNone/>
-                      </a:pPr>
-                      <a:r>
-                        <a:rPr lang="en-US" sz="1800" dirty="0"/>
-                        <a:t>3.75</a:t>
-                      </a:r>
-                      <a:endParaRPr sz="1800" b="0" i="0" u="none" strike="noStrike" cap="none" dirty="0">
-                        <a:solidFill>
-                          <a:srgbClr val="000000"/>
-                        </a:solidFill>
-                        <a:latin typeface="Arial"/>
-                        <a:ea typeface="Arial"/>
-                        <a:cs typeface="Arial"/>
-                        <a:sym typeface="Arial"/>
-                      </a:endParaRPr>
-                    </a:p>
-                  </a:txBody>
-                  <a:tcPr marL="43100" marR="43100" marT="43100" marB="43100">
-                    <a:lnL w="9525" cap="flat" cmpd="sng">
-                      <a:solidFill>
-                        <a:srgbClr val="000000"/>
-                      </a:solidFill>
-                      <a:prstDash val="solid"/>
-                      <a:round/>
-                      <a:headEnd type="none" w="sm" len="sm"/>
-                      <a:tailEnd type="none" w="sm" len="sm"/>
-                    </a:lnL>
-                    <a:lnR w="9525" cap="flat" cmpd="sng">
-                      <a:solidFill>
-                        <a:srgbClr val="000000"/>
-                      </a:solidFill>
-                      <a:prstDash val="solid"/>
-                      <a:round/>
-                      <a:headEnd type="none" w="sm" len="sm"/>
-                      <a:tailEnd type="none" w="sm" len="sm"/>
-                    </a:lnR>
-                    <a:lnT w="9525" cap="flat" cmpd="sng">
-                      <a:solidFill>
-                        <a:srgbClr val="000000"/>
-                      </a:solidFill>
-                      <a:prstDash val="solid"/>
-                      <a:round/>
-                      <a:headEnd type="none" w="sm" len="sm"/>
-                      <a:tailEnd type="none" w="sm" len="sm"/>
-                    </a:lnT>
-                    <a:lnB w="9525" cap="flat" cmpd="sng">
-                      <a:solidFill>
-                        <a:srgbClr val="000000"/>
-                      </a:solidFill>
-                      <a:prstDash val="solid"/>
-                      <a:round/>
-                      <a:headEnd type="none" w="sm" len="sm"/>
-                      <a:tailEnd type="none" w="sm" len="sm"/>
-                    </a:lnB>
-                  </a:tcPr>
-                </a:tc>
-                <a:tc>
-                  <a:txBody>
-                    <a:bodyPr/>
-                    <a:lstStyle/>
-                    <a:p>
-                      <a:pPr marL="0" marR="0" lvl="0" indent="0" algn="l" rtl="0">
-                        <a:spcBef>
-                          <a:spcPts val="0"/>
-                        </a:spcBef>
-                        <a:spcAft>
-                          <a:spcPts val="0"/>
-                        </a:spcAft>
-                        <a:buNone/>
-                      </a:pPr>
-                      <a:r>
-                        <a:rPr lang="en-US" sz="1800" dirty="0"/>
-                        <a:t>64</a:t>
-                      </a:r>
-                      <a:endParaRPr sz="1800" u="none" strike="noStrike" cap="none" dirty="0"/>
-                    </a:p>
-                  </a:txBody>
-                  <a:tcPr marL="43100" marR="43100" marT="43100" marB="43100">
-                    <a:lnL w="9525" cap="flat" cmpd="sng">
-                      <a:solidFill>
-                        <a:srgbClr val="000000"/>
-                      </a:solidFill>
-                      <a:prstDash val="solid"/>
-                      <a:round/>
-                      <a:headEnd type="none" w="sm" len="sm"/>
-                      <a:tailEnd type="none" w="sm" len="sm"/>
-                    </a:lnL>
-                    <a:lnR w="9525" cap="flat" cmpd="sng">
-                      <a:solidFill>
-                        <a:srgbClr val="000000"/>
-                      </a:solidFill>
-                      <a:prstDash val="solid"/>
-                      <a:round/>
-                      <a:headEnd type="none" w="sm" len="sm"/>
-                      <a:tailEnd type="none" w="sm" len="sm"/>
-                    </a:lnR>
-                    <a:lnT w="9525" cap="flat" cmpd="sng">
-                      <a:solidFill>
-                        <a:srgbClr val="000000"/>
-                      </a:solidFill>
-                      <a:prstDash val="solid"/>
-                      <a:round/>
-                      <a:headEnd type="none" w="sm" len="sm"/>
-                      <a:tailEnd type="none" w="sm" len="sm"/>
-                    </a:lnT>
-                    <a:lnB w="9525" cap="flat" cmpd="sng">
-                      <a:solidFill>
-                        <a:srgbClr val="000000"/>
-                      </a:solidFill>
-                      <a:prstDash val="solid"/>
-                      <a:round/>
-                      <a:headEnd type="none" w="sm" len="sm"/>
-                      <a:tailEnd type="none" w="sm" len="sm"/>
-                    </a:lnB>
-                  </a:tcPr>
-                </a:tc>
-                <a:tc>
-                  <a:txBody>
-                    <a:bodyPr/>
-                    <a:lstStyle/>
-                    <a:p>
-                      <a:pPr marL="0" marR="0" lvl="0" indent="0" algn="l" rtl="0">
-                        <a:spcBef>
-                          <a:spcPts val="0"/>
-                        </a:spcBef>
-                        <a:spcAft>
-                          <a:spcPts val="0"/>
-                        </a:spcAft>
-                        <a:buNone/>
-                      </a:pPr>
-                      <a:r>
-                        <a:rPr lang="en-US" sz="1800" b="0" i="0" u="none" strike="noStrike" cap="none" dirty="0">
-                          <a:solidFill>
-                            <a:srgbClr val="000000"/>
-                          </a:solidFill>
-                          <a:latin typeface="Arial"/>
-                          <a:ea typeface="Arial"/>
-                          <a:cs typeface="Arial"/>
-                          <a:sym typeface="Arial"/>
-                        </a:rPr>
-                        <a:t>0</a:t>
-                      </a:r>
-                      <a:endParaRPr sz="1800" u="none" strike="noStrike" cap="none" dirty="0"/>
-                    </a:p>
-                  </a:txBody>
-                  <a:tcPr marL="43100" marR="43100" marT="43100" marB="43100">
-                    <a:lnL w="9525" cap="flat" cmpd="sng">
-                      <a:solidFill>
-                        <a:srgbClr val="000000"/>
-                      </a:solidFill>
-                      <a:prstDash val="solid"/>
-                      <a:round/>
-                      <a:headEnd type="none" w="sm" len="sm"/>
-                      <a:tailEnd type="none" w="sm" len="sm"/>
-                    </a:lnL>
-                    <a:lnR w="9525" cap="flat" cmpd="sng">
-                      <a:solidFill>
-                        <a:srgbClr val="000000"/>
-                      </a:solidFill>
-                      <a:prstDash val="solid"/>
-                      <a:round/>
-                      <a:headEnd type="none" w="sm" len="sm"/>
-                      <a:tailEnd type="none" w="sm" len="sm"/>
-                    </a:lnR>
-                    <a:lnT w="9525" cap="flat" cmpd="sng">
-                      <a:solidFill>
-                        <a:srgbClr val="000000"/>
-                      </a:solidFill>
-                      <a:prstDash val="solid"/>
-                      <a:round/>
-                      <a:headEnd type="none" w="sm" len="sm"/>
-                      <a:tailEnd type="none" w="sm" len="sm"/>
-                    </a:lnT>
-                    <a:lnB w="9525" cap="flat" cmpd="sng">
-                      <a:solidFill>
-                        <a:srgbClr val="000000"/>
-                      </a:solidFill>
-                      <a:prstDash val="solid"/>
-                      <a:round/>
-                      <a:headEnd type="none" w="sm" len="sm"/>
-                      <a:tailEnd type="none" w="sm" len="sm"/>
-                    </a:lnB>
-                  </a:tcPr>
-                </a:tc>
-                <a:extLst>
-                  <a:ext uri="{0D108BD9-81ED-4DB2-BD59-A6C34878D82A}">
-                    <a16:rowId xmlns:a16="http://schemas.microsoft.com/office/drawing/2014/main" val="10001"/>
-                  </a:ext>
-                </a:extLst>
-              </a:tr>
-              <a:tr h="495175">
-                <a:tc>
-                  <a:txBody>
-                    <a:bodyPr/>
-                    <a:lstStyle/>
-                    <a:p>
-                      <a:pPr marL="0" marR="0" lvl="0" indent="0" algn="l" rtl="0">
-                        <a:spcBef>
-                          <a:spcPts val="0"/>
-                        </a:spcBef>
-                        <a:spcAft>
-                          <a:spcPts val="0"/>
-                        </a:spcAft>
-                        <a:buNone/>
-                      </a:pPr>
-                      <a:r>
-                        <a:rPr lang="en-US" dirty="0" err="1"/>
-                        <a:t>acompile</a:t>
-                      </a:r>
-                      <a:endParaRPr dirty="0"/>
-                    </a:p>
-                  </a:txBody>
-                  <a:tcPr marL="43100" marR="43100" marT="43100" marB="43100">
-                    <a:lnL w="9525" cap="flat" cmpd="sng">
-                      <a:solidFill>
-                        <a:srgbClr val="000000"/>
-                      </a:solidFill>
-                      <a:prstDash val="solid"/>
-                      <a:round/>
-                      <a:headEnd type="none" w="sm" len="sm"/>
-                      <a:tailEnd type="none" w="sm" len="sm"/>
-                    </a:lnL>
-                    <a:lnR w="9525" cap="flat" cmpd="sng" algn="ctr">
-                      <a:solidFill>
-                        <a:srgbClr val="000000"/>
-                      </a:solidFill>
-                      <a:prstDash val="solid"/>
-                      <a:round/>
-                      <a:headEnd type="none" w="sm" len="sm"/>
-                      <a:tailEnd type="none" w="sm" len="sm"/>
-                    </a:lnR>
-                    <a:lnT w="9525" cap="flat" cmpd="sng" algn="ctr">
-                      <a:solidFill>
-                        <a:srgbClr val="000000"/>
-                      </a:solidFill>
-                      <a:prstDash val="solid"/>
-                      <a:round/>
-                      <a:headEnd type="none" w="sm" len="sm"/>
-                      <a:tailEnd type="none" w="sm" len="sm"/>
-                    </a:lnT>
-                    <a:lnB w="9525" cap="flat" cmpd="sng">
-                      <a:solidFill>
-                        <a:srgbClr val="000000"/>
-                      </a:solidFill>
-                      <a:prstDash val="solid"/>
-                      <a:round/>
-                      <a:headEnd type="none" w="sm" len="sm"/>
-                      <a:tailEnd type="none" w="sm" len="sm"/>
-                    </a:lnB>
-                  </a:tcPr>
-                </a:tc>
-                <a:tc>
-                  <a:txBody>
-                    <a:bodyPr/>
-                    <a:lstStyle/>
-                    <a:p>
-                      <a:pPr marL="0" marR="0" lvl="0" indent="0" algn="l" rtl="0">
-                        <a:spcBef>
-                          <a:spcPts val="0"/>
-                        </a:spcBef>
-                        <a:spcAft>
-                          <a:spcPts val="0"/>
-                        </a:spcAft>
-                        <a:buNone/>
-                      </a:pPr>
-                      <a:r>
-                        <a:rPr lang="en-US" sz="1800" u="none" strike="noStrike" cap="none" dirty="0"/>
-                        <a:t>General Compute Node: AMD Milan</a:t>
-                      </a:r>
-                      <a:endParaRPr sz="1800" u="none" strike="noStrike" cap="none" dirty="0"/>
-                    </a:p>
-                  </a:txBody>
-                  <a:tcPr marL="43100" marR="43100" marT="43100" marB="43100">
-                    <a:lnL w="9525" cap="flat" cmpd="sng" algn="ctr">
-                      <a:solidFill>
-                        <a:srgbClr val="000000"/>
-                      </a:solidFill>
-                      <a:prstDash val="solid"/>
-                      <a:round/>
-                      <a:headEnd type="none" w="sm" len="sm"/>
-                      <a:tailEnd type="none" w="sm" len="sm"/>
-                    </a:lnL>
-                    <a:lnR w="9525" cap="flat" cmpd="sng" algn="ctr">
-                      <a:solidFill>
-                        <a:srgbClr val="000000"/>
-                      </a:solidFill>
-                      <a:prstDash val="solid"/>
-                      <a:round/>
-                      <a:headEnd type="none" w="sm" len="sm"/>
-                      <a:tailEnd type="none" w="sm" len="sm"/>
-                    </a:lnR>
-                    <a:lnT w="9525" cap="flat" cmpd="sng" algn="ctr">
-                      <a:solidFill>
-                        <a:srgbClr val="000000"/>
-                      </a:solidFill>
-                      <a:prstDash val="solid"/>
-                      <a:round/>
-                      <a:headEnd type="none" w="sm" len="sm"/>
-                      <a:tailEnd type="none" w="sm" len="sm"/>
-                    </a:lnT>
-                    <a:lnB w="9525" cap="flat" cmpd="sng">
-                      <a:solidFill>
-                        <a:srgbClr val="000000"/>
-                      </a:solidFill>
-                      <a:prstDash val="solid"/>
-                      <a:round/>
-                      <a:headEnd type="none" w="sm" len="sm"/>
-                      <a:tailEnd type="none" w="sm" len="sm"/>
-                    </a:lnB>
-                  </a:tcPr>
-                </a:tc>
-                <a:tc>
-                  <a:txBody>
-                    <a:bodyPr/>
-                    <a:lstStyle/>
-                    <a:p>
-                      <a:pPr marL="0" marR="0" lvl="0" indent="0" algn="l" rtl="0">
-                        <a:spcBef>
-                          <a:spcPts val="0"/>
-                        </a:spcBef>
-                        <a:spcAft>
-                          <a:spcPts val="0"/>
-                        </a:spcAft>
-                        <a:buNone/>
-                      </a:pPr>
-                      <a:r>
-                        <a:rPr lang="en-US" sz="1800" u="none" strike="noStrike" cap="none" dirty="0"/>
-                        <a:t>4</a:t>
-                      </a:r>
-                      <a:endParaRPr sz="1800" u="none" strike="noStrike" cap="none" dirty="0"/>
-                    </a:p>
-                  </a:txBody>
-                  <a:tcPr marL="43100" marR="43100" marT="43100" marB="43100">
-                    <a:lnL w="9525" cap="flat" cmpd="sng" algn="ctr">
-                      <a:solidFill>
-                        <a:srgbClr val="000000"/>
-                      </a:solidFill>
-                      <a:prstDash val="solid"/>
-                      <a:round/>
-                      <a:headEnd type="none" w="sm" len="sm"/>
-                      <a:tailEnd type="none" w="sm" len="sm"/>
-                    </a:lnL>
-                    <a:lnR w="9525" cap="flat" cmpd="sng" algn="ctr">
-                      <a:solidFill>
-                        <a:srgbClr val="000000"/>
-                      </a:solidFill>
-                      <a:prstDash val="solid"/>
-                      <a:round/>
-                      <a:headEnd type="none" w="sm" len="sm"/>
-                      <a:tailEnd type="none" w="sm" len="sm"/>
-                    </a:lnR>
-                    <a:lnT w="9525" cap="flat" cmpd="sng" algn="ctr">
-                      <a:solidFill>
-                        <a:srgbClr val="000000"/>
-                      </a:solidFill>
-                      <a:prstDash val="solid"/>
-                      <a:round/>
-                      <a:headEnd type="none" w="sm" len="sm"/>
-                      <a:tailEnd type="none" w="sm" len="sm"/>
-                    </a:lnT>
-                    <a:lnB w="9525" cap="flat" cmpd="sng">
-                      <a:solidFill>
-                        <a:srgbClr val="000000"/>
-                      </a:solidFill>
-                      <a:prstDash val="solid"/>
-                      <a:round/>
-                      <a:headEnd type="none" w="sm" len="sm"/>
-                      <a:tailEnd type="none" w="sm" len="sm"/>
-                    </a:lnB>
-                  </a:tcPr>
-                </a:tc>
-                <a:tc>
-                  <a:txBody>
-                    <a:bodyPr/>
-                    <a:lstStyle/>
-                    <a:p>
-                      <a:pPr marL="0" marR="0" lvl="0" indent="0" algn="l" rtl="0">
-                        <a:spcBef>
-                          <a:spcPts val="0"/>
-                        </a:spcBef>
-                        <a:spcAft>
-                          <a:spcPts val="0"/>
-                        </a:spcAft>
-                        <a:buNone/>
-                      </a:pPr>
-                      <a:r>
-                        <a:rPr lang="en-US" sz="1800" b="0" i="0" u="none" strike="noStrike" cap="none" dirty="0">
-                          <a:solidFill>
-                            <a:srgbClr val="000000"/>
-                          </a:solidFill>
-                          <a:latin typeface="Arial"/>
-                          <a:ea typeface="Arial"/>
-                          <a:cs typeface="Arial"/>
-                          <a:sym typeface="Arial"/>
-                        </a:rPr>
-                        <a:t>3.75</a:t>
-                      </a:r>
-                      <a:endParaRPr sz="1800" b="0" i="0" u="none" strike="noStrike" cap="none" dirty="0">
-                        <a:solidFill>
-                          <a:srgbClr val="000000"/>
-                        </a:solidFill>
-                        <a:latin typeface="Arial"/>
-                        <a:ea typeface="Arial"/>
-                        <a:cs typeface="Arial"/>
-                        <a:sym typeface="Arial"/>
-                      </a:endParaRPr>
-                    </a:p>
-                  </a:txBody>
-                  <a:tcPr marL="43100" marR="43100" marT="43100" marB="43100">
-                    <a:lnL w="9525" cap="flat" cmpd="sng" algn="ctr">
-                      <a:solidFill>
-                        <a:srgbClr val="000000"/>
-                      </a:solidFill>
-                      <a:prstDash val="solid"/>
-                      <a:round/>
-                      <a:headEnd type="none" w="sm" len="sm"/>
-                      <a:tailEnd type="none" w="sm" len="sm"/>
-                    </a:lnL>
-                    <a:lnR w="9525" cap="flat" cmpd="sng" algn="ctr">
-                      <a:solidFill>
-                        <a:srgbClr val="000000"/>
-                      </a:solidFill>
-                      <a:prstDash val="solid"/>
-                      <a:round/>
-                      <a:headEnd type="none" w="sm" len="sm"/>
-                      <a:tailEnd type="none" w="sm" len="sm"/>
-                    </a:lnR>
-                    <a:lnT w="9525" cap="flat" cmpd="sng" algn="ctr">
-                      <a:solidFill>
-                        <a:srgbClr val="000000"/>
-                      </a:solidFill>
-                      <a:prstDash val="solid"/>
-                      <a:round/>
-                      <a:headEnd type="none" w="sm" len="sm"/>
-                      <a:tailEnd type="none" w="sm" len="sm"/>
-                    </a:lnT>
-                    <a:lnB w="9525" cap="flat" cmpd="sng">
-                      <a:solidFill>
-                        <a:srgbClr val="000000"/>
-                      </a:solidFill>
-                      <a:prstDash val="solid"/>
-                      <a:round/>
-                      <a:headEnd type="none" w="sm" len="sm"/>
-                      <a:tailEnd type="none" w="sm" len="sm"/>
-                    </a:lnB>
-                  </a:tcPr>
-                </a:tc>
-                <a:tc>
-                  <a:txBody>
-                    <a:bodyPr/>
-                    <a:lstStyle/>
-                    <a:p>
-                      <a:pPr marL="0" marR="0" lvl="0" indent="0" algn="l" rtl="0">
-                        <a:spcBef>
-                          <a:spcPts val="0"/>
-                        </a:spcBef>
-                        <a:spcAft>
-                          <a:spcPts val="0"/>
-                        </a:spcAft>
-                        <a:buNone/>
-                      </a:pPr>
-                      <a:r>
-                        <a:rPr lang="en-US" sz="1800" u="none" strike="noStrike" cap="none" dirty="0"/>
-                        <a:t>64</a:t>
-                      </a:r>
-                      <a:endParaRPr sz="1800" u="none" strike="noStrike" cap="none" dirty="0"/>
-                    </a:p>
-                  </a:txBody>
-                  <a:tcPr marL="43100" marR="43100" marT="43100" marB="43100">
-                    <a:lnL w="9525" cap="flat" cmpd="sng" algn="ctr">
-                      <a:solidFill>
-                        <a:srgbClr val="000000"/>
-                      </a:solidFill>
-                      <a:prstDash val="solid"/>
-                      <a:round/>
-                      <a:headEnd type="none" w="sm" len="sm"/>
-                      <a:tailEnd type="none" w="sm" len="sm"/>
-                    </a:lnL>
-                    <a:lnR w="9525" cap="flat" cmpd="sng" algn="ctr">
-                      <a:solidFill>
-                        <a:srgbClr val="000000"/>
-                      </a:solidFill>
-                      <a:prstDash val="solid"/>
-                      <a:round/>
-                      <a:headEnd type="none" w="sm" len="sm"/>
-                      <a:tailEnd type="none" w="sm" len="sm"/>
-                    </a:lnR>
-                    <a:lnT w="9525" cap="flat" cmpd="sng" algn="ctr">
-                      <a:solidFill>
-                        <a:srgbClr val="000000"/>
-                      </a:solidFill>
-                      <a:prstDash val="solid"/>
-                      <a:round/>
-                      <a:headEnd type="none" w="sm" len="sm"/>
-                      <a:tailEnd type="none" w="sm" len="sm"/>
-                    </a:lnT>
-                    <a:lnB w="9525" cap="flat" cmpd="sng">
-                      <a:solidFill>
-                        <a:srgbClr val="000000"/>
-                      </a:solidFill>
-                      <a:prstDash val="solid"/>
-                      <a:round/>
-                      <a:headEnd type="none" w="sm" len="sm"/>
-                      <a:tailEnd type="none" w="sm" len="sm"/>
-                    </a:lnB>
-                  </a:tcPr>
-                </a:tc>
-                <a:tc>
-                  <a:txBody>
-                    <a:bodyPr/>
-                    <a:lstStyle/>
-                    <a:p>
-                      <a:pPr marL="0" marR="0" lvl="0" indent="0" algn="l" rtl="0">
-                        <a:spcBef>
-                          <a:spcPts val="0"/>
-                        </a:spcBef>
-                        <a:spcAft>
-                          <a:spcPts val="0"/>
-                        </a:spcAft>
-                        <a:buNone/>
-                      </a:pPr>
-                      <a:r>
-                        <a:rPr lang="en-US" sz="1800" u="none" strike="noStrike" cap="none" dirty="0"/>
-                        <a:t>0</a:t>
-                      </a:r>
-                      <a:endParaRPr sz="1800" u="none" strike="noStrike" cap="none" dirty="0"/>
-                    </a:p>
-                  </a:txBody>
-                  <a:tcPr marL="43100" marR="43100" marT="43100" marB="43100">
-                    <a:lnL w="9525" cap="flat" cmpd="sng" algn="ctr">
-                      <a:solidFill>
-                        <a:srgbClr val="000000"/>
-                      </a:solidFill>
-                      <a:prstDash val="solid"/>
-                      <a:round/>
-                      <a:headEnd type="none" w="sm" len="sm"/>
-                      <a:tailEnd type="none" w="sm" len="sm"/>
-                    </a:lnL>
-                    <a:lnR w="9525" cap="flat" cmpd="sng">
-                      <a:solidFill>
-                        <a:srgbClr val="000000"/>
-                      </a:solidFill>
-                      <a:prstDash val="solid"/>
-                      <a:round/>
-                      <a:headEnd type="none" w="sm" len="sm"/>
-                      <a:tailEnd type="none" w="sm" len="sm"/>
-                    </a:lnR>
-                    <a:lnT w="9525" cap="flat" cmpd="sng" algn="ctr">
-                      <a:solidFill>
-                        <a:srgbClr val="000000"/>
-                      </a:solidFill>
-                      <a:prstDash val="solid"/>
-                      <a:round/>
-                      <a:headEnd type="none" w="sm" len="sm"/>
-                      <a:tailEnd type="none" w="sm" len="sm"/>
-                    </a:lnT>
-                    <a:lnB w="9525" cap="flat" cmpd="sng">
-                      <a:solidFill>
-                        <a:srgbClr val="000000"/>
-                      </a:solidFill>
-                      <a:prstDash val="solid"/>
-                      <a:round/>
-                      <a:headEnd type="none" w="sm" len="sm"/>
-                      <a:tailEnd type="none" w="sm" len="sm"/>
-                    </a:lnB>
-                  </a:tcPr>
-                </a:tc>
-                <a:extLst>
-                  <a:ext uri="{0D108BD9-81ED-4DB2-BD59-A6C34878D82A}">
-                    <a16:rowId xmlns:a16="http://schemas.microsoft.com/office/drawing/2014/main" val="1275728692"/>
-                  </a:ext>
-                </a:extLst>
-              </a:tr>
-              <a:tr h="342475">
-                <a:tc>
-                  <a:txBody>
-                    <a:bodyPr/>
-                    <a:lstStyle/>
-                    <a:p>
-                      <a:pPr marL="0" marR="0" lvl="0" indent="0" algn="l" rtl="0">
-                        <a:spcBef>
-                          <a:spcPts val="0"/>
-                        </a:spcBef>
-                        <a:spcAft>
-                          <a:spcPts val="0"/>
-                        </a:spcAft>
-                        <a:buNone/>
-                      </a:pPr>
-                      <a:r>
-                        <a:rPr lang="en-US" sz="1800" dirty="0"/>
-                        <a:t>atesting_mi100</a:t>
-                      </a:r>
-                      <a:endParaRPr sz="1800" b="0" i="0" u="none" strike="noStrike" cap="none" dirty="0">
-                        <a:solidFill>
-                          <a:srgbClr val="000000"/>
-                        </a:solidFill>
-                        <a:latin typeface="Arial"/>
-                        <a:ea typeface="Arial"/>
-                        <a:cs typeface="Arial"/>
-                        <a:sym typeface="Arial"/>
-                      </a:endParaRPr>
-                    </a:p>
-                  </a:txBody>
-                  <a:tcPr marL="43100" marR="43100" marT="43100" marB="43100">
-                    <a:lnL w="9525" cap="flat" cmpd="sng">
-                      <a:solidFill>
-                        <a:srgbClr val="000000"/>
-                      </a:solidFill>
-                      <a:prstDash val="solid"/>
-                      <a:round/>
-                      <a:headEnd type="none" w="sm" len="sm"/>
-                      <a:tailEnd type="none" w="sm" len="sm"/>
-                    </a:lnL>
-                    <a:lnR w="9525" cap="flat" cmpd="sng">
-                      <a:solidFill>
-                        <a:srgbClr val="000000"/>
-                      </a:solidFill>
-                      <a:prstDash val="solid"/>
-                      <a:round/>
-                      <a:headEnd type="none" w="sm" len="sm"/>
-                      <a:tailEnd type="none" w="sm" len="sm"/>
-                    </a:lnR>
-                    <a:lnT w="9525" cap="flat" cmpd="sng">
-                      <a:solidFill>
-                        <a:srgbClr val="000000"/>
-                      </a:solidFill>
-                      <a:prstDash val="solid"/>
-                      <a:round/>
-                      <a:headEnd type="none" w="sm" len="sm"/>
-                      <a:tailEnd type="none" w="sm" len="sm"/>
-                    </a:lnT>
-                    <a:lnB w="9525" cap="flat" cmpd="sng">
-                      <a:solidFill>
-                        <a:srgbClr val="000000"/>
-                      </a:solidFill>
-                      <a:prstDash val="solid"/>
-                      <a:round/>
-                      <a:headEnd type="none" w="sm" len="sm"/>
-                      <a:tailEnd type="none" w="sm" len="sm"/>
-                    </a:lnB>
-                  </a:tcPr>
-                </a:tc>
-                <a:tc>
-                  <a:txBody>
-                    <a:bodyPr/>
-                    <a:lstStyle/>
-                    <a:p>
-                      <a:pPr marL="0" marR="0" lvl="0" indent="0" algn="l" rtl="0">
-                        <a:spcBef>
-                          <a:spcPts val="0"/>
-                        </a:spcBef>
-                        <a:spcAft>
-                          <a:spcPts val="0"/>
-                        </a:spcAft>
-                        <a:buNone/>
-                      </a:pPr>
-                      <a:r>
-                        <a:rPr lang="en-US" sz="1800" b="0" i="0" u="none" strike="noStrike" cap="none" dirty="0">
-                          <a:solidFill>
-                            <a:srgbClr val="000000"/>
-                          </a:solidFill>
-                          <a:latin typeface="Arial"/>
-                          <a:ea typeface="Arial"/>
-                          <a:cs typeface="Arial"/>
-                          <a:sym typeface="Arial"/>
-                        </a:rPr>
-                        <a:t>GPU </a:t>
-                      </a:r>
-                      <a:r>
-                        <a:rPr lang="en-US" sz="1800" dirty="0"/>
-                        <a:t>Node:</a:t>
-                      </a:r>
-                      <a:endParaRPr sz="1800" dirty="0"/>
-                    </a:p>
-                    <a:p>
-                      <a:pPr marL="0" marR="0" lvl="0" indent="0" algn="l" rtl="0">
-                        <a:spcBef>
-                          <a:spcPts val="0"/>
-                        </a:spcBef>
-                        <a:spcAft>
-                          <a:spcPts val="0"/>
-                        </a:spcAft>
-                        <a:buNone/>
-                      </a:pPr>
-                      <a:r>
-                        <a:rPr lang="en-US" sz="1800" dirty="0"/>
-                        <a:t>3x AMD MI100</a:t>
-                      </a:r>
-                      <a:endParaRPr sz="1800" dirty="0"/>
-                    </a:p>
-                  </a:txBody>
-                  <a:tcPr marL="43100" marR="43100" marT="43100" marB="43100">
-                    <a:lnL w="9525" cap="flat" cmpd="sng">
-                      <a:solidFill>
-                        <a:srgbClr val="000000"/>
-                      </a:solidFill>
-                      <a:prstDash val="solid"/>
-                      <a:round/>
-                      <a:headEnd type="none" w="sm" len="sm"/>
-                      <a:tailEnd type="none" w="sm" len="sm"/>
-                    </a:lnL>
-                    <a:lnR w="9525" cap="flat" cmpd="sng">
-                      <a:solidFill>
-                        <a:srgbClr val="000000"/>
-                      </a:solidFill>
-                      <a:prstDash val="solid"/>
-                      <a:round/>
-                      <a:headEnd type="none" w="sm" len="sm"/>
-                      <a:tailEnd type="none" w="sm" len="sm"/>
-                    </a:lnR>
-                    <a:lnT w="9525" cap="flat" cmpd="sng">
-                      <a:solidFill>
-                        <a:srgbClr val="000000"/>
-                      </a:solidFill>
-                      <a:prstDash val="solid"/>
-                      <a:round/>
-                      <a:headEnd type="none" w="sm" len="sm"/>
-                      <a:tailEnd type="none" w="sm" len="sm"/>
-                    </a:lnT>
-                    <a:lnB w="9525" cap="flat" cmpd="sng">
-                      <a:solidFill>
-                        <a:srgbClr val="000000"/>
-                      </a:solidFill>
-                      <a:prstDash val="solid"/>
-                      <a:round/>
-                      <a:headEnd type="none" w="sm" len="sm"/>
-                      <a:tailEnd type="none" w="sm" len="sm"/>
-                    </a:lnB>
-                  </a:tcPr>
-                </a:tc>
-                <a:tc>
-                  <a:txBody>
-                    <a:bodyPr/>
-                    <a:lstStyle/>
-                    <a:p>
-                      <a:pPr marL="0" marR="0" lvl="0" indent="0" algn="l" rtl="0">
-                        <a:spcBef>
-                          <a:spcPts val="0"/>
-                        </a:spcBef>
-                        <a:spcAft>
-                          <a:spcPts val="0"/>
-                        </a:spcAft>
-                        <a:buNone/>
-                      </a:pPr>
-                      <a:r>
-                        <a:rPr lang="en-US" sz="1800" u="none" strike="noStrike" cap="none" dirty="0"/>
-                        <a:t>1</a:t>
-                      </a:r>
-                      <a:endParaRPr sz="1800" u="none" strike="noStrike" cap="none" dirty="0"/>
-                    </a:p>
-                  </a:txBody>
-                  <a:tcPr marL="43100" marR="43100" marT="43100" marB="43100">
-                    <a:lnL w="9525" cap="flat" cmpd="sng">
-                      <a:solidFill>
-                        <a:srgbClr val="000000"/>
-                      </a:solidFill>
-                      <a:prstDash val="solid"/>
-                      <a:round/>
-                      <a:headEnd type="none" w="sm" len="sm"/>
-                      <a:tailEnd type="none" w="sm" len="sm"/>
-                    </a:lnL>
-                    <a:lnR w="9525" cap="flat" cmpd="sng">
-                      <a:solidFill>
-                        <a:srgbClr val="000000"/>
-                      </a:solidFill>
-                      <a:prstDash val="solid"/>
-                      <a:round/>
-                      <a:headEnd type="none" w="sm" len="sm"/>
-                      <a:tailEnd type="none" w="sm" len="sm"/>
-                    </a:lnR>
-                    <a:lnT w="9525" cap="flat" cmpd="sng">
-                      <a:solidFill>
-                        <a:srgbClr val="000000"/>
-                      </a:solidFill>
-                      <a:prstDash val="solid"/>
-                      <a:round/>
-                      <a:headEnd type="none" w="sm" len="sm"/>
-                      <a:tailEnd type="none" w="sm" len="sm"/>
-                    </a:lnT>
-                    <a:lnB w="9525" cap="flat" cmpd="sng">
-                      <a:solidFill>
-                        <a:srgbClr val="000000"/>
-                      </a:solidFill>
-                      <a:prstDash val="solid"/>
-                      <a:round/>
-                      <a:headEnd type="none" w="sm" len="sm"/>
-                      <a:tailEnd type="none" w="sm" len="sm"/>
-                    </a:lnB>
-                  </a:tcPr>
-                </a:tc>
-                <a:tc>
-                  <a:txBody>
-                    <a:bodyPr/>
-                    <a:lstStyle/>
-                    <a:p>
-                      <a:pPr marL="0" marR="0" lvl="0" indent="0" algn="l" rtl="0">
-                        <a:spcBef>
-                          <a:spcPts val="0"/>
-                        </a:spcBef>
-                        <a:spcAft>
-                          <a:spcPts val="0"/>
-                        </a:spcAft>
-                        <a:buNone/>
-                      </a:pPr>
-                      <a:r>
-                        <a:rPr lang="en-US" sz="1800" dirty="0"/>
-                        <a:t>3.75</a:t>
-                      </a:r>
-                      <a:endParaRPr sz="1800" b="0" i="0" u="none" strike="noStrike" cap="none" dirty="0">
-                        <a:solidFill>
-                          <a:srgbClr val="000000"/>
-                        </a:solidFill>
-                        <a:latin typeface="Arial"/>
-                        <a:ea typeface="Arial"/>
-                        <a:cs typeface="Arial"/>
-                        <a:sym typeface="Arial"/>
-                      </a:endParaRPr>
-                    </a:p>
-                  </a:txBody>
-                  <a:tcPr marL="43100" marR="43100" marT="43100" marB="43100">
-                    <a:lnL w="9525" cap="flat" cmpd="sng">
-                      <a:solidFill>
-                        <a:srgbClr val="000000"/>
-                      </a:solidFill>
-                      <a:prstDash val="solid"/>
-                      <a:round/>
-                      <a:headEnd type="none" w="sm" len="sm"/>
-                      <a:tailEnd type="none" w="sm" len="sm"/>
-                    </a:lnL>
-                    <a:lnR w="9525" cap="flat" cmpd="sng">
-                      <a:solidFill>
-                        <a:srgbClr val="000000"/>
-                      </a:solidFill>
-                      <a:prstDash val="solid"/>
-                      <a:round/>
-                      <a:headEnd type="none" w="sm" len="sm"/>
-                      <a:tailEnd type="none" w="sm" len="sm"/>
-                    </a:lnR>
-                    <a:lnT w="9525" cap="flat" cmpd="sng">
-                      <a:solidFill>
-                        <a:srgbClr val="000000"/>
-                      </a:solidFill>
-                      <a:prstDash val="solid"/>
-                      <a:round/>
-                      <a:headEnd type="none" w="sm" len="sm"/>
-                      <a:tailEnd type="none" w="sm" len="sm"/>
-                    </a:lnT>
-                    <a:lnB w="9525" cap="flat" cmpd="sng">
-                      <a:solidFill>
-                        <a:srgbClr val="000000"/>
-                      </a:solidFill>
-                      <a:prstDash val="solid"/>
-                      <a:round/>
-                      <a:headEnd type="none" w="sm" len="sm"/>
-                      <a:tailEnd type="none" w="sm" len="sm"/>
-                    </a:lnB>
-                  </a:tcPr>
-                </a:tc>
-                <a:tc>
-                  <a:txBody>
-                    <a:bodyPr/>
-                    <a:lstStyle/>
-                    <a:p>
-                      <a:pPr marL="0" marR="0" lvl="0" indent="0" algn="l" rtl="0">
-                        <a:spcBef>
-                          <a:spcPts val="0"/>
-                        </a:spcBef>
-                        <a:spcAft>
-                          <a:spcPts val="0"/>
-                        </a:spcAft>
-                        <a:buNone/>
-                      </a:pPr>
-                      <a:r>
-                        <a:rPr lang="en-US" sz="1800"/>
-                        <a:t>64</a:t>
-                      </a:r>
-                      <a:endParaRPr sz="1800" u="none" strike="noStrike" cap="none"/>
-                    </a:p>
-                  </a:txBody>
-                  <a:tcPr marL="43100" marR="43100" marT="43100" marB="43100">
-                    <a:lnL w="9525" cap="flat" cmpd="sng">
-                      <a:solidFill>
-                        <a:srgbClr val="000000"/>
-                      </a:solidFill>
-                      <a:prstDash val="solid"/>
-                      <a:round/>
-                      <a:headEnd type="none" w="sm" len="sm"/>
-                      <a:tailEnd type="none" w="sm" len="sm"/>
-                    </a:lnL>
-                    <a:lnR w="9525" cap="flat" cmpd="sng">
-                      <a:solidFill>
-                        <a:srgbClr val="000000"/>
-                      </a:solidFill>
-                      <a:prstDash val="solid"/>
-                      <a:round/>
-                      <a:headEnd type="none" w="sm" len="sm"/>
-                      <a:tailEnd type="none" w="sm" len="sm"/>
-                    </a:lnR>
-                    <a:lnT w="9525" cap="flat" cmpd="sng">
-                      <a:solidFill>
-                        <a:srgbClr val="000000"/>
-                      </a:solidFill>
-                      <a:prstDash val="solid"/>
-                      <a:round/>
-                      <a:headEnd type="none" w="sm" len="sm"/>
-                      <a:tailEnd type="none" w="sm" len="sm"/>
-                    </a:lnT>
-                    <a:lnB w="9525" cap="flat" cmpd="sng">
-                      <a:solidFill>
-                        <a:srgbClr val="000000"/>
-                      </a:solidFill>
-                      <a:prstDash val="solid"/>
-                      <a:round/>
-                      <a:headEnd type="none" w="sm" len="sm"/>
-                      <a:tailEnd type="none" w="sm" len="sm"/>
-                    </a:lnB>
-                  </a:tcPr>
-                </a:tc>
-                <a:tc>
-                  <a:txBody>
-                    <a:bodyPr/>
-                    <a:lstStyle/>
-                    <a:p>
-                      <a:pPr marL="0" marR="0" lvl="0" indent="0" algn="l" rtl="0">
-                        <a:spcBef>
-                          <a:spcPts val="0"/>
-                        </a:spcBef>
-                        <a:spcAft>
-                          <a:spcPts val="0"/>
-                        </a:spcAft>
-                        <a:buNone/>
-                      </a:pPr>
-                      <a:r>
-                        <a:rPr lang="en-US" sz="1800"/>
-                        <a:t>3</a:t>
-                      </a:r>
-                      <a:endParaRPr sz="1800" u="none" strike="noStrike" cap="none"/>
-                    </a:p>
-                  </a:txBody>
-                  <a:tcPr marL="43100" marR="43100" marT="43100" marB="43100">
-                    <a:lnL w="9525" cap="flat" cmpd="sng">
-                      <a:solidFill>
-                        <a:srgbClr val="000000"/>
-                      </a:solidFill>
-                      <a:prstDash val="solid"/>
-                      <a:round/>
-                      <a:headEnd type="none" w="sm" len="sm"/>
-                      <a:tailEnd type="none" w="sm" len="sm"/>
-                    </a:lnL>
-                    <a:lnR w="9525" cap="flat" cmpd="sng">
-                      <a:solidFill>
-                        <a:srgbClr val="000000"/>
-                      </a:solidFill>
-                      <a:prstDash val="solid"/>
-                      <a:round/>
-                      <a:headEnd type="none" w="sm" len="sm"/>
-                      <a:tailEnd type="none" w="sm" len="sm"/>
-                    </a:lnR>
-                    <a:lnT w="9525" cap="flat" cmpd="sng">
-                      <a:solidFill>
-                        <a:srgbClr val="000000"/>
-                      </a:solidFill>
-                      <a:prstDash val="solid"/>
-                      <a:round/>
-                      <a:headEnd type="none" w="sm" len="sm"/>
-                      <a:tailEnd type="none" w="sm" len="sm"/>
-                    </a:lnT>
-                    <a:lnB w="9525" cap="flat" cmpd="sng">
-                      <a:solidFill>
-                        <a:srgbClr val="000000"/>
-                      </a:solidFill>
-                      <a:prstDash val="solid"/>
-                      <a:round/>
-                      <a:headEnd type="none" w="sm" len="sm"/>
-                      <a:tailEnd type="none" w="sm" len="sm"/>
-                    </a:lnB>
-                  </a:tcPr>
-                </a:tc>
-                <a:extLst>
-                  <a:ext uri="{0D108BD9-81ED-4DB2-BD59-A6C34878D82A}">
-                    <a16:rowId xmlns:a16="http://schemas.microsoft.com/office/drawing/2014/main" val="10002"/>
-                  </a:ext>
-                </a:extLst>
-              </a:tr>
-              <a:tr h="347100">
-                <a:tc>
-                  <a:txBody>
-                    <a:bodyPr/>
-                    <a:lstStyle/>
-                    <a:p>
-                      <a:pPr marL="0" marR="0" lvl="0" indent="0" algn="l" rtl="0">
-                        <a:spcBef>
-                          <a:spcPts val="0"/>
-                        </a:spcBef>
-                        <a:spcAft>
-                          <a:spcPts val="0"/>
-                        </a:spcAft>
-                        <a:buNone/>
-                      </a:pPr>
-                      <a:r>
-                        <a:rPr lang="en-US" sz="1800" dirty="0"/>
-                        <a:t>atesting_a100</a:t>
-                      </a:r>
-                      <a:endParaRPr sz="1800" u="none" strike="noStrike" cap="none" dirty="0"/>
-                    </a:p>
-                  </a:txBody>
-                  <a:tcPr marL="43100" marR="43100" marT="43100" marB="43100">
-                    <a:lnL w="9525" cap="flat" cmpd="sng">
-                      <a:solidFill>
-                        <a:srgbClr val="000000"/>
-                      </a:solidFill>
-                      <a:prstDash val="solid"/>
-                      <a:round/>
-                      <a:headEnd type="none" w="sm" len="sm"/>
-                      <a:tailEnd type="none" w="sm" len="sm"/>
-                    </a:lnL>
-                    <a:lnR w="9525" cap="flat" cmpd="sng">
-                      <a:solidFill>
-                        <a:srgbClr val="000000"/>
-                      </a:solidFill>
-                      <a:prstDash val="solid"/>
-                      <a:round/>
-                      <a:headEnd type="none" w="sm" len="sm"/>
-                      <a:tailEnd type="none" w="sm" len="sm"/>
-                    </a:lnR>
-                    <a:lnT w="9525" cap="flat" cmpd="sng">
-                      <a:solidFill>
-                        <a:srgbClr val="000000"/>
-                      </a:solidFill>
-                      <a:prstDash val="solid"/>
-                      <a:round/>
-                      <a:headEnd type="none" w="sm" len="sm"/>
-                      <a:tailEnd type="none" w="sm" len="sm"/>
-                    </a:lnT>
-                    <a:lnB w="9525" cap="flat" cmpd="sng" algn="ctr">
-                      <a:solidFill>
-                        <a:srgbClr val="000000"/>
-                      </a:solidFill>
-                      <a:prstDash val="solid"/>
-                      <a:round/>
-                      <a:headEnd type="none" w="sm" len="sm"/>
-                      <a:tailEnd type="none" w="sm" len="sm"/>
-                    </a:lnB>
-                  </a:tcPr>
-                </a:tc>
-                <a:tc>
-                  <a:txBody>
-                    <a:bodyPr/>
-                    <a:lstStyle/>
-                    <a:p>
-                      <a:pPr marL="0" marR="0" lvl="0" indent="0" algn="l" rtl="0">
-                        <a:spcBef>
-                          <a:spcPts val="0"/>
-                        </a:spcBef>
-                        <a:spcAft>
-                          <a:spcPts val="0"/>
-                        </a:spcAft>
-                        <a:buNone/>
-                      </a:pPr>
-                      <a:r>
-                        <a:rPr lang="en-US" sz="1800" dirty="0"/>
-                        <a:t>GPU Node:</a:t>
-                      </a:r>
-                      <a:endParaRPr sz="1800" dirty="0"/>
-                    </a:p>
-                    <a:p>
-                      <a:pPr marL="0" marR="0" lvl="0" indent="0" algn="l" rtl="0">
-                        <a:spcBef>
-                          <a:spcPts val="0"/>
-                        </a:spcBef>
-                        <a:spcAft>
-                          <a:spcPts val="0"/>
-                        </a:spcAft>
-                        <a:buNone/>
-                      </a:pPr>
-                      <a:r>
-                        <a:rPr lang="en-US" sz="1800" dirty="0"/>
-                        <a:t>3x Nvidia A100</a:t>
-                      </a:r>
-                      <a:endParaRPr sz="1800" dirty="0"/>
-                    </a:p>
-                  </a:txBody>
-                  <a:tcPr marL="43100" marR="43100" marT="43100" marB="43100">
-                    <a:lnL w="9525" cap="flat" cmpd="sng">
-                      <a:solidFill>
-                        <a:srgbClr val="000000"/>
-                      </a:solidFill>
-                      <a:prstDash val="solid"/>
-                      <a:round/>
-                      <a:headEnd type="none" w="sm" len="sm"/>
-                      <a:tailEnd type="none" w="sm" len="sm"/>
-                    </a:lnL>
-                    <a:lnR w="9525" cap="flat" cmpd="sng">
-                      <a:solidFill>
-                        <a:srgbClr val="000000"/>
-                      </a:solidFill>
-                      <a:prstDash val="solid"/>
-                      <a:round/>
-                      <a:headEnd type="none" w="sm" len="sm"/>
-                      <a:tailEnd type="none" w="sm" len="sm"/>
-                    </a:lnR>
-                    <a:lnT w="9525" cap="flat" cmpd="sng">
-                      <a:solidFill>
-                        <a:srgbClr val="000000"/>
-                      </a:solidFill>
-                      <a:prstDash val="solid"/>
-                      <a:round/>
-                      <a:headEnd type="none" w="sm" len="sm"/>
-                      <a:tailEnd type="none" w="sm" len="sm"/>
-                    </a:lnT>
-                    <a:lnB w="9525" cap="flat" cmpd="sng" algn="ctr">
-                      <a:solidFill>
-                        <a:srgbClr val="000000"/>
-                      </a:solidFill>
-                      <a:prstDash val="solid"/>
-                      <a:round/>
-                      <a:headEnd type="none" w="sm" len="sm"/>
-                      <a:tailEnd type="none" w="sm" len="sm"/>
-                    </a:lnB>
-                  </a:tcPr>
-                </a:tc>
-                <a:tc>
-                  <a:txBody>
-                    <a:bodyPr/>
-                    <a:lstStyle/>
-                    <a:p>
-                      <a:pPr marL="0" marR="0" lvl="0" indent="0" algn="l" rtl="0">
-                        <a:spcBef>
-                          <a:spcPts val="0"/>
-                        </a:spcBef>
-                        <a:spcAft>
-                          <a:spcPts val="0"/>
-                        </a:spcAft>
-                        <a:buNone/>
-                      </a:pPr>
-                      <a:r>
-                        <a:rPr lang="en-US" sz="1800" u="none" strike="noStrike" cap="none" dirty="0"/>
-                        <a:t>1</a:t>
-                      </a:r>
-                      <a:endParaRPr sz="1800" u="none" strike="noStrike" cap="none" dirty="0"/>
-                    </a:p>
-                  </a:txBody>
-                  <a:tcPr marL="43100" marR="43100" marT="43100" marB="43100">
-                    <a:lnL w="9525" cap="flat" cmpd="sng">
-                      <a:solidFill>
-                        <a:srgbClr val="000000"/>
-                      </a:solidFill>
-                      <a:prstDash val="solid"/>
-                      <a:round/>
-                      <a:headEnd type="none" w="sm" len="sm"/>
-                      <a:tailEnd type="none" w="sm" len="sm"/>
-                    </a:lnL>
-                    <a:lnR w="9525" cap="flat" cmpd="sng">
-                      <a:solidFill>
-                        <a:srgbClr val="000000"/>
-                      </a:solidFill>
-                      <a:prstDash val="solid"/>
-                      <a:round/>
-                      <a:headEnd type="none" w="sm" len="sm"/>
-                      <a:tailEnd type="none" w="sm" len="sm"/>
-                    </a:lnR>
-                    <a:lnT w="9525" cap="flat" cmpd="sng">
-                      <a:solidFill>
-                        <a:srgbClr val="000000"/>
-                      </a:solidFill>
-                      <a:prstDash val="solid"/>
-                      <a:round/>
-                      <a:headEnd type="none" w="sm" len="sm"/>
-                      <a:tailEnd type="none" w="sm" len="sm"/>
-                    </a:lnT>
-                    <a:lnB w="9525" cap="flat" cmpd="sng" algn="ctr">
-                      <a:solidFill>
-                        <a:srgbClr val="000000"/>
-                      </a:solidFill>
-                      <a:prstDash val="solid"/>
-                      <a:round/>
-                      <a:headEnd type="none" w="sm" len="sm"/>
-                      <a:tailEnd type="none" w="sm" len="sm"/>
-                    </a:lnB>
-                  </a:tcPr>
-                </a:tc>
-                <a:tc>
-                  <a:txBody>
-                    <a:bodyPr/>
-                    <a:lstStyle/>
-                    <a:p>
-                      <a:pPr marL="0" marR="0" lvl="0" indent="0" algn="l" rtl="0">
-                        <a:spcBef>
-                          <a:spcPts val="0"/>
-                        </a:spcBef>
-                        <a:spcAft>
-                          <a:spcPts val="0"/>
-                        </a:spcAft>
-                        <a:buNone/>
-                      </a:pPr>
-                      <a:r>
-                        <a:rPr lang="en-US" sz="1800" dirty="0"/>
-                        <a:t>3.75</a:t>
-                      </a:r>
-                      <a:endParaRPr sz="1800" b="0" i="0" u="none" strike="noStrike" cap="none" dirty="0">
-                        <a:solidFill>
-                          <a:srgbClr val="000000"/>
-                        </a:solidFill>
-                        <a:latin typeface="Arial"/>
-                        <a:ea typeface="Arial"/>
-                        <a:cs typeface="Arial"/>
-                        <a:sym typeface="Arial"/>
-                      </a:endParaRPr>
-                    </a:p>
-                  </a:txBody>
-                  <a:tcPr marL="43100" marR="43100" marT="43100" marB="43100">
-                    <a:lnL w="9525" cap="flat" cmpd="sng">
-                      <a:solidFill>
-                        <a:srgbClr val="000000"/>
-                      </a:solidFill>
-                      <a:prstDash val="solid"/>
-                      <a:round/>
-                      <a:headEnd type="none" w="sm" len="sm"/>
-                      <a:tailEnd type="none" w="sm" len="sm"/>
-                    </a:lnL>
-                    <a:lnR w="9525" cap="flat" cmpd="sng">
-                      <a:solidFill>
-                        <a:srgbClr val="000000"/>
-                      </a:solidFill>
-                      <a:prstDash val="solid"/>
-                      <a:round/>
-                      <a:headEnd type="none" w="sm" len="sm"/>
-                      <a:tailEnd type="none" w="sm" len="sm"/>
-                    </a:lnR>
-                    <a:lnT w="9525" cap="flat" cmpd="sng">
-                      <a:solidFill>
-                        <a:srgbClr val="000000"/>
-                      </a:solidFill>
-                      <a:prstDash val="solid"/>
-                      <a:round/>
-                      <a:headEnd type="none" w="sm" len="sm"/>
-                      <a:tailEnd type="none" w="sm" len="sm"/>
-                    </a:lnT>
-                    <a:lnB w="9525" cap="flat" cmpd="sng" algn="ctr">
-                      <a:solidFill>
-                        <a:srgbClr val="000000"/>
-                      </a:solidFill>
-                      <a:prstDash val="solid"/>
-                      <a:round/>
-                      <a:headEnd type="none" w="sm" len="sm"/>
-                      <a:tailEnd type="none" w="sm" len="sm"/>
-                    </a:lnB>
-                  </a:tcPr>
-                </a:tc>
-                <a:tc>
-                  <a:txBody>
-                    <a:bodyPr/>
-                    <a:lstStyle/>
-                    <a:p>
-                      <a:pPr marL="0" marR="0" lvl="0" indent="0" algn="l" rtl="0">
-                        <a:spcBef>
-                          <a:spcPts val="0"/>
-                        </a:spcBef>
-                        <a:spcAft>
-                          <a:spcPts val="0"/>
-                        </a:spcAft>
-                        <a:buNone/>
-                      </a:pPr>
-                      <a:r>
-                        <a:rPr lang="en-US" sz="1800" dirty="0"/>
-                        <a:t>64</a:t>
-                      </a:r>
-                      <a:endParaRPr sz="1800" u="none" strike="noStrike" cap="none" dirty="0"/>
-                    </a:p>
-                  </a:txBody>
-                  <a:tcPr marL="43100" marR="43100" marT="43100" marB="43100">
-                    <a:lnL w="9525" cap="flat" cmpd="sng">
-                      <a:solidFill>
-                        <a:srgbClr val="000000"/>
-                      </a:solidFill>
-                      <a:prstDash val="solid"/>
-                      <a:round/>
-                      <a:headEnd type="none" w="sm" len="sm"/>
-                      <a:tailEnd type="none" w="sm" len="sm"/>
-                    </a:lnL>
-                    <a:lnR w="9525" cap="flat" cmpd="sng">
-                      <a:solidFill>
-                        <a:srgbClr val="000000"/>
-                      </a:solidFill>
-                      <a:prstDash val="solid"/>
-                      <a:round/>
-                      <a:headEnd type="none" w="sm" len="sm"/>
-                      <a:tailEnd type="none" w="sm" len="sm"/>
-                    </a:lnR>
-                    <a:lnT w="9525" cap="flat" cmpd="sng">
-                      <a:solidFill>
-                        <a:srgbClr val="000000"/>
-                      </a:solidFill>
-                      <a:prstDash val="solid"/>
-                      <a:round/>
-                      <a:headEnd type="none" w="sm" len="sm"/>
-                      <a:tailEnd type="none" w="sm" len="sm"/>
-                    </a:lnT>
-                    <a:lnB w="9525" cap="flat" cmpd="sng" algn="ctr">
-                      <a:solidFill>
-                        <a:srgbClr val="000000"/>
-                      </a:solidFill>
-                      <a:prstDash val="solid"/>
-                      <a:round/>
-                      <a:headEnd type="none" w="sm" len="sm"/>
-                      <a:tailEnd type="none" w="sm" len="sm"/>
-                    </a:lnB>
-                  </a:tcPr>
-                </a:tc>
-                <a:tc>
-                  <a:txBody>
-                    <a:bodyPr/>
-                    <a:lstStyle/>
-                    <a:p>
-                      <a:pPr marL="0" marR="0" lvl="0" indent="0" algn="l" rtl="0">
-                        <a:spcBef>
-                          <a:spcPts val="0"/>
-                        </a:spcBef>
-                        <a:spcAft>
-                          <a:spcPts val="0"/>
-                        </a:spcAft>
-                        <a:buNone/>
-                      </a:pPr>
-                      <a:r>
-                        <a:rPr lang="en-US" sz="1800" u="none" strike="noStrike" cap="none" dirty="0"/>
-                        <a:t>6 MIG instances</a:t>
-                      </a:r>
-                      <a:endParaRPr sz="1800" u="none" strike="noStrike" cap="none" dirty="0"/>
-                    </a:p>
-                  </a:txBody>
-                  <a:tcPr marL="43100" marR="43100" marT="43100" marB="43100">
-                    <a:lnL w="9525" cap="flat" cmpd="sng">
-                      <a:solidFill>
-                        <a:srgbClr val="000000"/>
-                      </a:solidFill>
-                      <a:prstDash val="solid"/>
-                      <a:round/>
-                      <a:headEnd type="none" w="sm" len="sm"/>
-                      <a:tailEnd type="none" w="sm" len="sm"/>
-                    </a:lnL>
-                    <a:lnR w="9525" cap="flat" cmpd="sng">
-                      <a:solidFill>
-                        <a:srgbClr val="000000"/>
-                      </a:solidFill>
-                      <a:prstDash val="solid"/>
-                      <a:round/>
-                      <a:headEnd type="none" w="sm" len="sm"/>
-                      <a:tailEnd type="none" w="sm" len="sm"/>
-                    </a:lnR>
-                    <a:lnT w="9525" cap="flat" cmpd="sng">
-                      <a:solidFill>
-                        <a:srgbClr val="000000"/>
-                      </a:solidFill>
-                      <a:prstDash val="solid"/>
-                      <a:round/>
-                      <a:headEnd type="none" w="sm" len="sm"/>
-                      <a:tailEnd type="none" w="sm" len="sm"/>
-                    </a:lnT>
-                    <a:lnB w="9525" cap="flat" cmpd="sng" algn="ctr">
-                      <a:solidFill>
-                        <a:srgbClr val="000000"/>
-                      </a:solidFill>
-                      <a:prstDash val="solid"/>
-                      <a:round/>
-                      <a:headEnd type="none" w="sm" len="sm"/>
-                      <a:tailEnd type="none" w="sm" len="sm"/>
-                    </a:lnB>
-                  </a:tcPr>
-                </a:tc>
-                <a:extLst>
-                  <a:ext uri="{0D108BD9-81ED-4DB2-BD59-A6C34878D82A}">
-                    <a16:rowId xmlns:a16="http://schemas.microsoft.com/office/drawing/2014/main" val="10003"/>
-                  </a:ext>
-                </a:extLst>
-              </a:tr>
-            </a:tbl>
-          </a:graphicData>
-        </a:graphic>
-      </p:graphicFrame>
-    </p:spTree>
-    <p:extLst>
-      <p:ext uri="{BB962C8B-B14F-4D97-AF65-F5344CB8AC3E}">
-        <p14:creationId xmlns:p14="http://schemas.microsoft.com/office/powerpoint/2010/main" val="415197255"/>
-      </p:ext>
-    </p:extLst>
-  </p:cSld>
-  <p:clrMapOvr>
-    <a:masterClrMapping/>
-  </p:clrMapOvr>
-</p:sld>
-</file>
-
-<file path=ppt/slides/slide14.xml><?xml version="1.0" encoding="utf-8"?>
 <p:sld xmlns:a="http://schemas.openxmlformats.org/drawingml/2006/main" xmlns:r="http://schemas.openxmlformats.org/officeDocument/2006/relationships" xmlns:p="http://schemas.openxmlformats.org/presentationml/2006/main">
   <p:cSld>
     <p:spTree>
@@ -25382,7 +23151,7 @@
 </p:sld>
 </file>
 
-<file path=ppt/slides/slide15.xml><?xml version="1.0" encoding="utf-8"?>
+<file path=ppt/slides/slide14.xml><?xml version="1.0" encoding="utf-8"?>
 <p:sld xmlns:a="http://schemas.openxmlformats.org/drawingml/2006/main" xmlns:r="http://schemas.openxmlformats.org/officeDocument/2006/relationships" xmlns:p="http://schemas.openxmlformats.org/presentationml/2006/main">
   <p:cSld>
     <p:spTree>
@@ -25526,7 +23295,7 @@
                   <a:srgbClr val="2F2B20"/>
                 </a:solidFill>
               </a:rPr>
-              <a:t>A job script is simply a script that includes </a:t>
+              <a:t>A job script is simply a file that includes </a:t>
             </a:r>
             <a:r>
               <a:rPr lang="en-US" b="1" dirty="0">
@@ -25592,7 +23361,7 @@
 </p:sld>
 </file>
 
-<file path=ppt/slides/slide16.xml><?xml version="1.0" encoding="utf-8"?>
+<file path=ppt/slides/slide15.xml><?xml version="1.0" encoding="utf-8"?>
 <p:sld xmlns:a="http://schemas.openxmlformats.org/drawingml/2006/main" xmlns:r="http://schemas.openxmlformats.org/officeDocument/2006/relationships" xmlns:p="http://schemas.openxmlformats.org/presentationml/2006/main">
   <p:cSld>
     <p:spTree>
@@ -26020,7 +23789,7 @@
 </p:sld>
 </file>
 
-<file path=ppt/slides/slide17.xml><?xml version="1.0" encoding="utf-8"?>
+<file path=ppt/slides/slide16.xml><?xml version="1.0" encoding="utf-8"?>
 <p:sld xmlns:a="http://schemas.openxmlformats.org/drawingml/2006/main" xmlns:r="http://schemas.openxmlformats.org/officeDocument/2006/relationships" xmlns:p="http://schemas.openxmlformats.org/presentationml/2006/main">
   <p:cSld>
     <p:spTree>
@@ -26168,7 +23937,7 @@
 </p:sld>
 </file>
 
-<file path=ppt/slides/slide18.xml><?xml version="1.0" encoding="utf-8"?>
+<file path=ppt/slides/slide17.xml><?xml version="1.0" encoding="utf-8"?>
 <p:sld xmlns:a="http://schemas.openxmlformats.org/drawingml/2006/main" xmlns:r="http://schemas.openxmlformats.org/officeDocument/2006/relationships" xmlns:p="http://schemas.openxmlformats.org/presentationml/2006/main">
   <p:cSld>
     <p:spTree>
@@ -26895,7 +24664,7 @@
 </p:sld>
 </file>
 
-<file path=ppt/slides/slide19.xml><?xml version="1.0" encoding="utf-8"?>
+<file path=ppt/slides/slide18.xml><?xml version="1.0" encoding="utf-8"?>
 <p:sld xmlns:a="http://schemas.openxmlformats.org/drawingml/2006/main" xmlns:r="http://schemas.openxmlformats.org/officeDocument/2006/relationships" xmlns:p="http://schemas.openxmlformats.org/presentationml/2006/main">
   <p:cSld>
     <p:spTree>
@@ -27270,6 +25039,321 @@
     <p:extLst>
       <p:ext uri="{BB962C8B-B14F-4D97-AF65-F5344CB8AC3E}">
         <p14:creationId xmlns:p14="http://schemas.microsoft.com/office/powerpoint/2010/main" val="2223687286"/>
+      </p:ext>
+    </p:extLst>
+  </p:cSld>
+  <p:clrMapOvr>
+    <a:masterClrMapping/>
+  </p:clrMapOvr>
+</p:sld>
+</file>
+
+<file path=ppt/slides/slide19.xml><?xml version="1.0" encoding="utf-8"?>
+<p:sld xmlns:a="http://schemas.openxmlformats.org/drawingml/2006/main" xmlns:r="http://schemas.openxmlformats.org/officeDocument/2006/relationships" xmlns:p="http://schemas.openxmlformats.org/presentationml/2006/main">
+  <p:cSld>
+    <p:spTree>
+      <p:nvGrpSpPr>
+        <p:cNvPr id="1" name=""/>
+        <p:cNvGrpSpPr/>
+        <p:nvPr/>
+      </p:nvGrpSpPr>
+      <p:grpSpPr>
+        <a:xfrm>
+          <a:off x="0" y="0"/>
+          <a:ext cx="0" cy="0"/>
+          <a:chOff x="0" y="0"/>
+          <a:chExt cx="0" cy="0"/>
+        </a:xfrm>
+      </p:grpSpPr>
+      <p:sp>
+        <p:nvSpPr>
+          <p:cNvPr id="2" name="Title 1">
+            <a:extLst>
+              <a:ext uri="{FF2B5EF4-FFF2-40B4-BE49-F238E27FC236}">
+                <a16:creationId xmlns:a16="http://schemas.microsoft.com/office/drawing/2014/main" id="{2C40115A-840C-5AF8-2E78-FBF510397E59}"/>
+              </a:ext>
+            </a:extLst>
+          </p:cNvPr>
+          <p:cNvSpPr>
+            <a:spLocks noGrp="1"/>
+          </p:cNvSpPr>
+          <p:nvPr>
+            <p:ph type="title"/>
+          </p:nvPr>
+        </p:nvSpPr>
+        <p:spPr/>
+        <p:txBody>
+          <a:bodyPr/>
+          <a:lstStyle/>
+          <a:p>
+            <a:r>
+              <a:rPr lang="en-US" b="1" dirty="0">
+                <a:latin typeface="Century Gothic" panose="020B0502020202020204" pitchFamily="34" charset="0"/>
+              </a:rPr>
+              <a:t>Job output</a:t>
+            </a:r>
+          </a:p>
+        </p:txBody>
+      </p:sp>
+      <p:sp>
+        <p:nvSpPr>
+          <p:cNvPr id="3" name="Content Placeholder 2">
+            <a:extLst>
+              <a:ext uri="{FF2B5EF4-FFF2-40B4-BE49-F238E27FC236}">
+                <a16:creationId xmlns:a16="http://schemas.microsoft.com/office/drawing/2014/main" id="{AE7BEDD6-7036-93C6-793A-10B1A333CE33}"/>
+              </a:ext>
+            </a:extLst>
+          </p:cNvPr>
+          <p:cNvSpPr>
+            <a:spLocks noGrp="1"/>
+          </p:cNvSpPr>
+          <p:nvPr>
+            <p:ph idx="1"/>
+          </p:nvPr>
+        </p:nvSpPr>
+        <p:spPr>
+          <a:xfrm>
+            <a:off x="838200" y="2101849"/>
+            <a:ext cx="10515600" cy="3203575"/>
+          </a:xfrm>
+        </p:spPr>
+        <p:txBody>
+          <a:bodyPr>
+            <a:normAutofit lnSpcReduction="10000"/>
+          </a:bodyPr>
+          <a:lstStyle/>
+          <a:p>
+            <a:pPr marL="228600" marR="0" lvl="0" indent="-222250" algn="l" rtl="0">
+              <a:lnSpc>
+                <a:spcPct val="90000"/>
+              </a:lnSpc>
+              <a:spcBef>
+                <a:spcPts val="0"/>
+              </a:spcBef>
+              <a:spcAft>
+                <a:spcPts val="800"/>
+              </a:spcAft>
+              <a:buClr>
+                <a:schemeClr val="dk1"/>
+              </a:buClr>
+              <a:buSzPts val="2700"/>
+              <a:buChar char="•"/>
+            </a:pPr>
+            <a:r>
+              <a:rPr lang="en-US" sz="2700" dirty="0">
+                <a:solidFill>
+                  <a:schemeClr val="dk1"/>
+                </a:solidFill>
+              </a:rPr>
+              <a:t>Once a job completes its execution, the standard output of the script will be redirected to an output file.</a:t>
+            </a:r>
+            <a:endParaRPr lang="en-US" sz="1300" dirty="0"/>
+          </a:p>
+          <a:p>
+            <a:pPr marL="685800" marR="0" lvl="1" indent="-335915" algn="l" rtl="0">
+              <a:lnSpc>
+                <a:spcPct val="90000"/>
+              </a:lnSpc>
+              <a:spcBef>
+                <a:spcPts val="500"/>
+              </a:spcBef>
+              <a:spcAft>
+                <a:spcPts val="800"/>
+              </a:spcAft>
+              <a:buClr>
+                <a:schemeClr val="dk1"/>
+              </a:buClr>
+              <a:buSzPts val="2300"/>
+              <a:buChar char="•"/>
+            </a:pPr>
+            <a:r>
+              <a:rPr lang="en-US" sz="2300" i="0" u="none" strike="noStrike" cap="none" dirty="0">
+                <a:solidFill>
+                  <a:schemeClr val="dk1"/>
+                </a:solidFill>
+              </a:rPr>
+              <a:t>Great for debugging!</a:t>
+            </a:r>
+            <a:endParaRPr lang="en-US" sz="1300" dirty="0"/>
+          </a:p>
+          <a:p>
+            <a:pPr marL="685800" marR="0" lvl="1" indent="-335915" algn="l" rtl="0">
+              <a:lnSpc>
+                <a:spcPct val="90000"/>
+              </a:lnSpc>
+              <a:spcBef>
+                <a:spcPts val="500"/>
+              </a:spcBef>
+              <a:spcAft>
+                <a:spcPts val="800"/>
+              </a:spcAft>
+              <a:buClr>
+                <a:schemeClr val="dk1"/>
+              </a:buClr>
+              <a:buSzPts val="2300"/>
+              <a:buChar char="•"/>
+            </a:pPr>
+            <a:r>
+              <a:rPr lang="en-US" sz="2300" i="0" u="none" strike="noStrike" cap="none" dirty="0">
+                <a:solidFill>
+                  <a:schemeClr val="dk1"/>
+                </a:solidFill>
+              </a:rPr>
+              <a:t>Could be different from output generated by your application</a:t>
+            </a:r>
+            <a:endParaRPr lang="en-US" sz="1300" dirty="0"/>
+          </a:p>
+          <a:p>
+            <a:pPr marL="685800" marR="0" lvl="1" indent="-335915" algn="l" rtl="0">
+              <a:lnSpc>
+                <a:spcPct val="90000"/>
+              </a:lnSpc>
+              <a:spcBef>
+                <a:spcPts val="500"/>
+              </a:spcBef>
+              <a:spcAft>
+                <a:spcPts val="800"/>
+              </a:spcAft>
+              <a:buClr>
+                <a:schemeClr val="dk1"/>
+              </a:buClr>
+              <a:buSzPts val="2300"/>
+              <a:buChar char="•"/>
+            </a:pPr>
+            <a:r>
+              <a:rPr lang="en-US" sz="2300" i="0" u="none" strike="noStrike" cap="none" dirty="0">
+                <a:solidFill>
+                  <a:schemeClr val="dk1"/>
+                </a:solidFill>
+              </a:rPr>
+              <a:t>File is created in directory where job was run unless specified in your </a:t>
+            </a:r>
+            <a:br>
+              <a:rPr lang="en-US" sz="2300" i="0" u="none" strike="noStrike" cap="none" dirty="0">
+                <a:solidFill>
+                  <a:schemeClr val="dk1"/>
+                </a:solidFill>
+              </a:rPr>
+            </a:br>
+            <a:r>
+              <a:rPr lang="en-US" sz="2300" i="0" u="none" strike="noStrike" cap="none" dirty="0">
+                <a:solidFill>
+                  <a:srgbClr val="0070C0"/>
+                </a:solidFill>
+              </a:rPr>
+              <a:t>--output </a:t>
+            </a:r>
+            <a:r>
+              <a:rPr lang="en-US" sz="2300" i="0" u="none" strike="noStrike" cap="none" dirty="0">
+                <a:solidFill>
+                  <a:schemeClr val="dk1"/>
+                </a:solidFill>
+              </a:rPr>
+              <a:t>directive.</a:t>
+            </a:r>
+            <a:endParaRPr lang="en-US" sz="1300" dirty="0"/>
+          </a:p>
+          <a:p>
+            <a:pPr marL="685800" marR="0" lvl="1" indent="-335915" algn="l" rtl="0">
+              <a:lnSpc>
+                <a:spcPct val="90000"/>
+              </a:lnSpc>
+              <a:spcBef>
+                <a:spcPts val="500"/>
+              </a:spcBef>
+              <a:spcAft>
+                <a:spcPts val="800"/>
+              </a:spcAft>
+              <a:buClr>
+                <a:schemeClr val="dk1"/>
+              </a:buClr>
+              <a:buSzPts val="2300"/>
+              <a:buChar char="•"/>
+            </a:pPr>
+            <a:r>
+              <a:rPr lang="en-US" sz="2300" i="0" u="none" strike="noStrike" cap="none" dirty="0">
+                <a:solidFill>
+                  <a:schemeClr val="dk1"/>
+                </a:solidFill>
+              </a:rPr>
+              <a:t>If the </a:t>
+            </a:r>
+            <a:r>
+              <a:rPr lang="en-US" sz="2300" i="0" u="none" strike="noStrike" cap="none" dirty="0">
+                <a:solidFill>
+                  <a:srgbClr val="000000"/>
+                </a:solidFill>
+              </a:rPr>
+              <a:t>directive </a:t>
+            </a:r>
+            <a:r>
+              <a:rPr lang="en-US" sz="2300" i="0" u="none" strike="noStrike" cap="none" dirty="0">
+                <a:solidFill>
+                  <a:srgbClr val="0070C0"/>
+                </a:solidFill>
+              </a:rPr>
+              <a:t>--output </a:t>
+            </a:r>
+            <a:r>
+              <a:rPr lang="en-US" sz="2300" i="0" u="none" strike="noStrike" cap="none" dirty="0">
+                <a:solidFill>
+                  <a:schemeClr val="dk1"/>
+                </a:solidFill>
+              </a:rPr>
+              <a:t>is not provided, then a generic file name will be used (</a:t>
+            </a:r>
+            <a:r>
+              <a:rPr lang="en-US" sz="2300" i="0" u="none" strike="noStrike" cap="none" dirty="0" err="1">
+                <a:solidFill>
+                  <a:schemeClr val="dk1"/>
+                </a:solidFill>
+              </a:rPr>
+              <a:t>slurm_xxxxxx.out</a:t>
+            </a:r>
+            <a:r>
+              <a:rPr lang="en-US" sz="2300" i="0" u="none" strike="noStrike" cap="none" dirty="0">
+                <a:solidFill>
+                  <a:schemeClr val="dk1"/>
+                </a:solidFill>
+              </a:rPr>
+              <a:t>).</a:t>
+            </a:r>
+          </a:p>
+        </p:txBody>
+      </p:sp>
+      <p:sp>
+        <p:nvSpPr>
+          <p:cNvPr id="4" name="Date Placeholder 3">
+            <a:extLst>
+              <a:ext uri="{FF2B5EF4-FFF2-40B4-BE49-F238E27FC236}">
+                <a16:creationId xmlns:a16="http://schemas.microsoft.com/office/drawing/2014/main" id="{17555D82-6283-7363-24EF-7EDA92D09849}"/>
+              </a:ext>
+            </a:extLst>
+          </p:cNvPr>
+          <p:cNvSpPr>
+            <a:spLocks noGrp="1"/>
+          </p:cNvSpPr>
+          <p:nvPr>
+            <p:ph type="dt" sz="half" idx="10"/>
+          </p:nvPr>
+        </p:nvSpPr>
+        <p:spPr/>
+        <p:txBody>
+          <a:bodyPr/>
+          <a:lstStyle/>
+          <a:p>
+            <a:pPr algn="ctr"/>
+            <a:r>
+              <a:rPr lang="en-US"/>
+              <a:t>8/12/26</a:t>
+            </a:r>
+          </a:p>
+        </p:txBody>
+      </p:sp>
+    </p:spTree>
+    <p:extLst>
+      <p:ext uri="{BB962C8B-B14F-4D97-AF65-F5344CB8AC3E}">
+        <p14:creationId xmlns:p14="http://schemas.microsoft.com/office/powerpoint/2010/main" val="3742081296"/>
       </p:ext>
     </p:extLst>
   </p:cSld>
@@ -27465,321 +25549,6 @@
           <p:cNvPr id="2" name="Title 1">
             <a:extLst>
               <a:ext uri="{FF2B5EF4-FFF2-40B4-BE49-F238E27FC236}">
-                <a16:creationId xmlns:a16="http://schemas.microsoft.com/office/drawing/2014/main" id="{2C40115A-840C-5AF8-2E78-FBF510397E59}"/>
-              </a:ext>
-            </a:extLst>
-          </p:cNvPr>
-          <p:cNvSpPr>
-            <a:spLocks noGrp="1"/>
-          </p:cNvSpPr>
-          <p:nvPr>
-            <p:ph type="title"/>
-          </p:nvPr>
-        </p:nvSpPr>
-        <p:spPr/>
-        <p:txBody>
-          <a:bodyPr/>
-          <a:lstStyle/>
-          <a:p>
-            <a:r>
-              <a:rPr lang="en-US" b="1" dirty="0">
-                <a:latin typeface="Century Gothic" panose="020B0502020202020204" pitchFamily="34" charset="0"/>
-              </a:rPr>
-              <a:t>Job output</a:t>
-            </a:r>
-          </a:p>
-        </p:txBody>
-      </p:sp>
-      <p:sp>
-        <p:nvSpPr>
-          <p:cNvPr id="3" name="Content Placeholder 2">
-            <a:extLst>
-              <a:ext uri="{FF2B5EF4-FFF2-40B4-BE49-F238E27FC236}">
-                <a16:creationId xmlns:a16="http://schemas.microsoft.com/office/drawing/2014/main" id="{AE7BEDD6-7036-93C6-793A-10B1A333CE33}"/>
-              </a:ext>
-            </a:extLst>
-          </p:cNvPr>
-          <p:cNvSpPr>
-            <a:spLocks noGrp="1"/>
-          </p:cNvSpPr>
-          <p:nvPr>
-            <p:ph idx="1"/>
-          </p:nvPr>
-        </p:nvSpPr>
-        <p:spPr>
-          <a:xfrm>
-            <a:off x="838200" y="2101849"/>
-            <a:ext cx="10515600" cy="3203575"/>
-          </a:xfrm>
-        </p:spPr>
-        <p:txBody>
-          <a:bodyPr>
-            <a:normAutofit lnSpcReduction="10000"/>
-          </a:bodyPr>
-          <a:lstStyle/>
-          <a:p>
-            <a:pPr marL="228600" marR="0" lvl="0" indent="-222250" algn="l" rtl="0">
-              <a:lnSpc>
-                <a:spcPct val="90000"/>
-              </a:lnSpc>
-              <a:spcBef>
-                <a:spcPts val="0"/>
-              </a:spcBef>
-              <a:spcAft>
-                <a:spcPts val="800"/>
-              </a:spcAft>
-              <a:buClr>
-                <a:schemeClr val="dk1"/>
-              </a:buClr>
-              <a:buSzPts val="2700"/>
-              <a:buChar char="•"/>
-            </a:pPr>
-            <a:r>
-              <a:rPr lang="en-US" sz="2700" dirty="0">
-                <a:solidFill>
-                  <a:schemeClr val="dk1"/>
-                </a:solidFill>
-              </a:rPr>
-              <a:t>Once a job completes its execution, the standard output of the script will be redirected to an output file.</a:t>
-            </a:r>
-            <a:endParaRPr lang="en-US" sz="1300" dirty="0"/>
-          </a:p>
-          <a:p>
-            <a:pPr marL="685800" marR="0" lvl="1" indent="-335915" algn="l" rtl="0">
-              <a:lnSpc>
-                <a:spcPct val="90000"/>
-              </a:lnSpc>
-              <a:spcBef>
-                <a:spcPts val="500"/>
-              </a:spcBef>
-              <a:spcAft>
-                <a:spcPts val="800"/>
-              </a:spcAft>
-              <a:buClr>
-                <a:schemeClr val="dk1"/>
-              </a:buClr>
-              <a:buSzPts val="2300"/>
-              <a:buChar char="•"/>
-            </a:pPr>
-            <a:r>
-              <a:rPr lang="en-US" sz="2300" i="0" u="none" strike="noStrike" cap="none" dirty="0">
-                <a:solidFill>
-                  <a:schemeClr val="dk1"/>
-                </a:solidFill>
-              </a:rPr>
-              <a:t>Great for debugging!</a:t>
-            </a:r>
-            <a:endParaRPr lang="en-US" sz="1300" dirty="0"/>
-          </a:p>
-          <a:p>
-            <a:pPr marL="685800" marR="0" lvl="1" indent="-335915" algn="l" rtl="0">
-              <a:lnSpc>
-                <a:spcPct val="90000"/>
-              </a:lnSpc>
-              <a:spcBef>
-                <a:spcPts val="500"/>
-              </a:spcBef>
-              <a:spcAft>
-                <a:spcPts val="800"/>
-              </a:spcAft>
-              <a:buClr>
-                <a:schemeClr val="dk1"/>
-              </a:buClr>
-              <a:buSzPts val="2300"/>
-              <a:buChar char="•"/>
-            </a:pPr>
-            <a:r>
-              <a:rPr lang="en-US" sz="2300" i="0" u="none" strike="noStrike" cap="none" dirty="0">
-                <a:solidFill>
-                  <a:schemeClr val="dk1"/>
-                </a:solidFill>
-              </a:rPr>
-              <a:t>Could be different from output generated by your application</a:t>
-            </a:r>
-            <a:endParaRPr lang="en-US" sz="1300" dirty="0"/>
-          </a:p>
-          <a:p>
-            <a:pPr marL="685800" marR="0" lvl="1" indent="-335915" algn="l" rtl="0">
-              <a:lnSpc>
-                <a:spcPct val="90000"/>
-              </a:lnSpc>
-              <a:spcBef>
-                <a:spcPts val="500"/>
-              </a:spcBef>
-              <a:spcAft>
-                <a:spcPts val="800"/>
-              </a:spcAft>
-              <a:buClr>
-                <a:schemeClr val="dk1"/>
-              </a:buClr>
-              <a:buSzPts val="2300"/>
-              <a:buChar char="•"/>
-            </a:pPr>
-            <a:r>
-              <a:rPr lang="en-US" sz="2300" i="0" u="none" strike="noStrike" cap="none" dirty="0">
-                <a:solidFill>
-                  <a:schemeClr val="dk1"/>
-                </a:solidFill>
-              </a:rPr>
-              <a:t>File is created in directory where job was run unless specified in your </a:t>
-            </a:r>
-            <a:br>
-              <a:rPr lang="en-US" sz="2300" i="0" u="none" strike="noStrike" cap="none" dirty="0">
-                <a:solidFill>
-                  <a:schemeClr val="dk1"/>
-                </a:solidFill>
-              </a:rPr>
-            </a:br>
-            <a:r>
-              <a:rPr lang="en-US" sz="2300" i="0" u="none" strike="noStrike" cap="none" dirty="0">
-                <a:solidFill>
-                  <a:srgbClr val="0070C0"/>
-                </a:solidFill>
-              </a:rPr>
-              <a:t>--output </a:t>
-            </a:r>
-            <a:r>
-              <a:rPr lang="en-US" sz="2300" i="0" u="none" strike="noStrike" cap="none" dirty="0">
-                <a:solidFill>
-                  <a:schemeClr val="dk1"/>
-                </a:solidFill>
-              </a:rPr>
-              <a:t>directive.</a:t>
-            </a:r>
-            <a:endParaRPr lang="en-US" sz="1300" dirty="0"/>
-          </a:p>
-          <a:p>
-            <a:pPr marL="685800" marR="0" lvl="1" indent="-335915" algn="l" rtl="0">
-              <a:lnSpc>
-                <a:spcPct val="90000"/>
-              </a:lnSpc>
-              <a:spcBef>
-                <a:spcPts val="500"/>
-              </a:spcBef>
-              <a:spcAft>
-                <a:spcPts val="800"/>
-              </a:spcAft>
-              <a:buClr>
-                <a:schemeClr val="dk1"/>
-              </a:buClr>
-              <a:buSzPts val="2300"/>
-              <a:buChar char="•"/>
-            </a:pPr>
-            <a:r>
-              <a:rPr lang="en-US" sz="2300" i="0" u="none" strike="noStrike" cap="none" dirty="0">
-                <a:solidFill>
-                  <a:schemeClr val="dk1"/>
-                </a:solidFill>
-              </a:rPr>
-              <a:t>If the </a:t>
-            </a:r>
-            <a:r>
-              <a:rPr lang="en-US" sz="2300" i="0" u="none" strike="noStrike" cap="none" dirty="0">
-                <a:solidFill>
-                  <a:srgbClr val="000000"/>
-                </a:solidFill>
-              </a:rPr>
-              <a:t>directive </a:t>
-            </a:r>
-            <a:r>
-              <a:rPr lang="en-US" sz="2300" i="0" u="none" strike="noStrike" cap="none" dirty="0">
-                <a:solidFill>
-                  <a:srgbClr val="0070C0"/>
-                </a:solidFill>
-              </a:rPr>
-              <a:t>--output </a:t>
-            </a:r>
-            <a:r>
-              <a:rPr lang="en-US" sz="2300" i="0" u="none" strike="noStrike" cap="none" dirty="0">
-                <a:solidFill>
-                  <a:schemeClr val="dk1"/>
-                </a:solidFill>
-              </a:rPr>
-              <a:t>is not provided, then a generic file name will be used (</a:t>
-            </a:r>
-            <a:r>
-              <a:rPr lang="en-US" sz="2300" i="0" u="none" strike="noStrike" cap="none" dirty="0" err="1">
-                <a:solidFill>
-                  <a:schemeClr val="dk1"/>
-                </a:solidFill>
-              </a:rPr>
-              <a:t>slurm_xxxxxx.out</a:t>
-            </a:r>
-            <a:r>
-              <a:rPr lang="en-US" sz="2300" i="0" u="none" strike="noStrike" cap="none" dirty="0">
-                <a:solidFill>
-                  <a:schemeClr val="dk1"/>
-                </a:solidFill>
-              </a:rPr>
-              <a:t>).</a:t>
-            </a:r>
-          </a:p>
-        </p:txBody>
-      </p:sp>
-      <p:sp>
-        <p:nvSpPr>
-          <p:cNvPr id="4" name="Date Placeholder 3">
-            <a:extLst>
-              <a:ext uri="{FF2B5EF4-FFF2-40B4-BE49-F238E27FC236}">
-                <a16:creationId xmlns:a16="http://schemas.microsoft.com/office/drawing/2014/main" id="{17555D82-6283-7363-24EF-7EDA92D09849}"/>
-              </a:ext>
-            </a:extLst>
-          </p:cNvPr>
-          <p:cNvSpPr>
-            <a:spLocks noGrp="1"/>
-          </p:cNvSpPr>
-          <p:nvPr>
-            <p:ph type="dt" sz="half" idx="10"/>
-          </p:nvPr>
-        </p:nvSpPr>
-        <p:spPr/>
-        <p:txBody>
-          <a:bodyPr/>
-          <a:lstStyle/>
-          <a:p>
-            <a:pPr algn="ctr"/>
-            <a:r>
-              <a:rPr lang="en-US"/>
-              <a:t>8/12/26</a:t>
-            </a:r>
-          </a:p>
-        </p:txBody>
-      </p:sp>
-    </p:spTree>
-    <p:extLst>
-      <p:ext uri="{BB962C8B-B14F-4D97-AF65-F5344CB8AC3E}">
-        <p14:creationId xmlns:p14="http://schemas.microsoft.com/office/powerpoint/2010/main" val="3742081296"/>
-      </p:ext>
-    </p:extLst>
-  </p:cSld>
-  <p:clrMapOvr>
-    <a:masterClrMapping/>
-  </p:clrMapOvr>
-</p:sld>
-</file>
-
-<file path=ppt/slides/slide21.xml><?xml version="1.0" encoding="utf-8"?>
-<p:sld xmlns:a="http://schemas.openxmlformats.org/drawingml/2006/main" xmlns:r="http://schemas.openxmlformats.org/officeDocument/2006/relationships" xmlns:p="http://schemas.openxmlformats.org/presentationml/2006/main">
-  <p:cSld>
-    <p:spTree>
-      <p:nvGrpSpPr>
-        <p:cNvPr id="1" name=""/>
-        <p:cNvGrpSpPr/>
-        <p:nvPr/>
-      </p:nvGrpSpPr>
-      <p:grpSpPr>
-        <a:xfrm>
-          <a:off x="0" y="0"/>
-          <a:ext cx="0" cy="0"/>
-          <a:chOff x="0" y="0"/>
-          <a:chExt cx="0" cy="0"/>
-        </a:xfrm>
-      </p:grpSpPr>
-      <p:sp>
-        <p:nvSpPr>
-          <p:cNvPr id="2" name="Title 1">
-            <a:extLst>
-              <a:ext uri="{FF2B5EF4-FFF2-40B4-BE49-F238E27FC236}">
                 <a16:creationId xmlns:a16="http://schemas.microsoft.com/office/drawing/2014/main" id="{F5275463-50BF-24AF-3C10-D30FBDDEC803}"/>
               </a:ext>
             </a:extLst>
@@ -28417,7 +26186,7 @@
 </p:sld>
 </file>
 
-<file path=ppt/slides/slide22.xml><?xml version="1.0" encoding="utf-8"?>
+<file path=ppt/slides/slide21.xml><?xml version="1.0" encoding="utf-8"?>
 <p:sld xmlns:a="http://schemas.openxmlformats.org/drawingml/2006/main" xmlns:r="http://schemas.openxmlformats.org/officeDocument/2006/relationships" xmlns:p="http://schemas.openxmlformats.org/presentationml/2006/main">
   <p:cSld>
     <p:spTree>
@@ -28596,7 +26365,7 @@
 </p:sld>
 </file>
 
-<file path=ppt/slides/slide23.xml><?xml version="1.0" encoding="utf-8"?>
+<file path=ppt/slides/slide22.xml><?xml version="1.0" encoding="utf-8"?>
 <p:sld xmlns:a="http://schemas.openxmlformats.org/drawingml/2006/main" xmlns:r="http://schemas.openxmlformats.org/officeDocument/2006/relationships" xmlns:p="http://schemas.openxmlformats.org/presentationml/2006/main">
   <p:cSld>
     <p:spTree>
@@ -29384,7 +27153,7 @@
 </p:sld>
 </file>
 
-<file path=ppt/slides/slide24.xml><?xml version="1.0" encoding="utf-8"?>
+<file path=ppt/slides/slide23.xml><?xml version="1.0" encoding="utf-8"?>
 <p:sld xmlns:a="http://schemas.openxmlformats.org/drawingml/2006/main" xmlns:r="http://schemas.openxmlformats.org/officeDocument/2006/relationships" xmlns:p="http://schemas.openxmlformats.org/presentationml/2006/main">
   <p:cSld>
     <p:spTree>
@@ -29637,7 +27406,7 @@
 </p:sld>
 </file>
 
-<file path=ppt/slides/slide25.xml><?xml version="1.0" encoding="utf-8"?>
+<file path=ppt/slides/slide24.xml><?xml version="1.0" encoding="utf-8"?>
 <p:sld xmlns:a="http://schemas.openxmlformats.org/drawingml/2006/main" xmlns:r="http://schemas.openxmlformats.org/officeDocument/2006/relationships" xmlns:p="http://schemas.openxmlformats.org/presentationml/2006/main">
   <p:cSld>
     <p:spTree>
@@ -30180,7 +27949,7 @@
 </p:sld>
 </file>
 
-<file path=ppt/slides/slide26.xml><?xml version="1.0" encoding="utf-8"?>
+<file path=ppt/slides/slide25.xml><?xml version="1.0" encoding="utf-8"?>
 <p:sld xmlns:a="http://schemas.openxmlformats.org/drawingml/2006/main" xmlns:r="http://schemas.openxmlformats.org/officeDocument/2006/relationships" xmlns:p="http://schemas.openxmlformats.org/presentationml/2006/main">
   <p:cSld>
     <p:spTree>
@@ -30350,7 +28119,7 @@
 </p:sld>
 </file>
 
-<file path=ppt/slides/slide27.xml><?xml version="1.0" encoding="utf-8"?>
+<file path=ppt/slides/slide26.xml><?xml version="1.0" encoding="utf-8"?>
 <p:sld xmlns:a="http://schemas.openxmlformats.org/drawingml/2006/main" xmlns:r="http://schemas.openxmlformats.org/officeDocument/2006/relationships" xmlns:p="http://schemas.openxmlformats.org/presentationml/2006/main">
   <p:cSld>
     <p:spTree>

</xml_diff>